<commit_message>
Made the ppt diagram render better
</commit_message>
<xml_diff>
--- a/ai_solution_architect_v2/backend/services/pptx_gen/test_output.pptx
+++ b/ai_solution_architect_v2/backend/services/pptx_gen/test_output.pptx
@@ -9255,29 +9255,3002 @@
           </a:p>
         </p:txBody>
       </p:sp>
-      <p:pic>
-        <p:nvPicPr>
-          <p:cNvPr id="11" name="Image 1" descr="preencoded.png">    </p:cNvPr>
-          <p:cNvPicPr>
-            <a:picLocks noChangeAspect="1"/>
-          </p:cNvPicPr>
-          <p:nvPr/>
-        </p:nvPicPr>
-        <p:blipFill>
-          <a:blip r:embed="rId2"/>
-          <a:srcRect l="0" r="0" t="0" b="0"/>
-          <a:stretch/>
-        </p:blipFill>
-        <p:spPr>
-          <a:xfrm>
-            <a:off x="164592" y="786384"/>
-            <a:ext cx="8887968" cy="4027932"/>
-          </a:xfrm>
-          <a:prstGeom prst="rect">
-            <a:avLst/>
-          </a:prstGeom>
-        </p:spPr>
-      </p:pic>
+      <p:sp>
+        <p:nvSpPr>
+          <p:cNvPr id="11" name="Shape 8"/>
+          <p:cNvSpPr/>
+          <p:nvPr/>
+        </p:nvSpPr>
+        <p:spPr>
+          <a:xfrm>
+            <a:off x="164592" y="749808"/>
+            <a:ext cx="2121408" cy="4160520"/>
+          </a:xfrm>
+          <a:prstGeom prst="roundRect">
+            <a:avLst>
+              <a:gd name="adj" fmla="val 2155"/>
+            </a:avLst>
+          </a:prstGeom>
+          <a:solidFill>
+            <a:srgbClr val="F8FAFC"/>
+          </a:solidFill>
+          <a:ln w="12700">
+            <a:solidFill>
+              <a:srgbClr val="3B82F6"/>
+            </a:solidFill>
+            <a:prstDash val="solid"/>
+          </a:ln>
+        </p:spPr>
+      </p:sp>
+      <p:sp>
+        <p:nvSpPr>
+          <p:cNvPr id="12" name="Shape 9"/>
+          <p:cNvSpPr/>
+          <p:nvPr/>
+        </p:nvSpPr>
+        <p:spPr>
+          <a:xfrm>
+            <a:off x="164592" y="749808"/>
+            <a:ext cx="2121408" cy="384048"/>
+          </a:xfrm>
+          <a:prstGeom prst="roundRect">
+            <a:avLst>
+              <a:gd name="adj" fmla="val 11905"/>
+            </a:avLst>
+          </a:prstGeom>
+          <a:solidFill>
+            <a:srgbClr val="1D4ED8"/>
+          </a:solidFill>
+          <a:ln w="1270">
+            <a:solidFill>
+              <a:srgbClr val="1D4ED8"/>
+            </a:solidFill>
+            <a:prstDash val="solid"/>
+          </a:ln>
+        </p:spPr>
+      </p:sp>
+      <p:sp>
+        <p:nvSpPr>
+          <p:cNvPr id="13" name="Shape 10"/>
+          <p:cNvSpPr/>
+          <p:nvPr/>
+        </p:nvSpPr>
+        <p:spPr>
+          <a:xfrm>
+            <a:off x="164592" y="941832"/>
+            <a:ext cx="2121408" cy="192024"/>
+          </a:xfrm>
+          <a:prstGeom prst="rect">
+            <a:avLst/>
+          </a:prstGeom>
+          <a:solidFill>
+            <a:srgbClr val="1D4ED8"/>
+          </a:solidFill>
+          <a:ln w="1270">
+            <a:solidFill>
+              <a:srgbClr val="1D4ED8"/>
+            </a:solidFill>
+            <a:prstDash val="solid"/>
+          </a:ln>
+        </p:spPr>
+      </p:sp>
+      <p:sp>
+        <p:nvSpPr>
+          <p:cNvPr id="14" name="Text 11"/>
+          <p:cNvSpPr/>
+          <p:nvPr/>
+        </p:nvSpPr>
+        <p:spPr>
+          <a:xfrm>
+            <a:off x="164592" y="749808"/>
+            <a:ext cx="2121408" cy="384048"/>
+          </a:xfrm>
+          <a:prstGeom prst="rect">
+            <a:avLst/>
+          </a:prstGeom>
+          <a:noFill/>
+          <a:ln/>
+        </p:spPr>
+        <p:txBody>
+          <a:bodyPr wrap="square" lIns="0" tIns="0" rIns="0" bIns="0" rtlCol="0" anchor="ctr"/>
+          <a:lstStyle/>
+          <a:p>
+            <a:pPr algn="ctr" indent="0" marL="0">
+              <a:buNone/>
+            </a:pPr>
+            <a:r>
+              <a:rPr lang="en-US" sz="850" b="1" dirty="0">
+                <a:solidFill>
+                  <a:srgbClr val="FFFFFF"/>
+                </a:solidFill>
+                <a:latin typeface="Calibri" pitchFamily="34" charset="0"/>
+                <a:ea typeface="Calibri" pitchFamily="34" charset="-122"/>
+                <a:cs typeface="Calibri" pitchFamily="34" charset="-120"/>
+              </a:rPr>
+              <a:t>CLIENT</a:t>
+            </a:r>
+            <a:endParaRPr lang="en-US" sz="850" dirty="0"/>
+          </a:p>
+        </p:txBody>
+      </p:sp>
+      <p:sp>
+        <p:nvSpPr>
+          <p:cNvPr id="15" name="Shape 12"/>
+          <p:cNvSpPr/>
+          <p:nvPr/>
+        </p:nvSpPr>
+        <p:spPr>
+          <a:xfrm>
+            <a:off x="256032" y="1280160"/>
+            <a:ext cx="1938528" cy="621792"/>
+          </a:xfrm>
+          <a:prstGeom prst="roundRect">
+            <a:avLst>
+              <a:gd name="adj" fmla="val 7353"/>
+            </a:avLst>
+          </a:prstGeom>
+          <a:solidFill>
+            <a:srgbClr val="DBEAFE"/>
+          </a:solidFill>
+          <a:ln w="22860">
+            <a:solidFill>
+              <a:srgbClr val="3B82F6"/>
+            </a:solidFill>
+            <a:prstDash val="solid"/>
+          </a:ln>
+        </p:spPr>
+      </p:sp>
+      <p:sp>
+        <p:nvSpPr>
+          <p:cNvPr id="16" name="Shape 13"/>
+          <p:cNvSpPr/>
+          <p:nvPr/>
+        </p:nvSpPr>
+        <p:spPr>
+          <a:xfrm>
+            <a:off x="347472" y="1280160"/>
+            <a:ext cx="1755648" cy="50292"/>
+          </a:xfrm>
+          <a:prstGeom prst="rect">
+            <a:avLst/>
+          </a:prstGeom>
+          <a:solidFill>
+            <a:srgbClr val="3B82F6"/>
+          </a:solidFill>
+          <a:ln w="1270">
+            <a:solidFill>
+              <a:srgbClr val="3B82F6"/>
+            </a:solidFill>
+            <a:prstDash val="solid"/>
+          </a:ln>
+        </p:spPr>
+      </p:sp>
+      <p:sp>
+        <p:nvSpPr>
+          <p:cNvPr id="17" name="Text 14"/>
+          <p:cNvSpPr/>
+          <p:nvPr/>
+        </p:nvSpPr>
+        <p:spPr>
+          <a:xfrm>
+            <a:off x="310896" y="1330452"/>
+            <a:ext cx="1828800" cy="297180"/>
+          </a:xfrm>
+          <a:prstGeom prst="rect">
+            <a:avLst/>
+          </a:prstGeom>
+          <a:noFill/>
+          <a:ln/>
+        </p:spPr>
+        <p:txBody>
+          <a:bodyPr wrap="square" lIns="0" tIns="0" rIns="0" bIns="0" rtlCol="0" anchor="ctr"/>
+          <a:lstStyle/>
+          <a:p>
+            <a:pPr algn="ctr" indent="0" marL="0">
+              <a:buNone/>
+            </a:pPr>
+            <a:r>
+              <a:rPr lang="en-US" sz="950" b="1" dirty="0">
+                <a:solidFill>
+                  <a:srgbClr val="1E3A8A"/>
+                </a:solidFill>
+                <a:latin typeface="Calibri" pitchFamily="34" charset="0"/>
+                <a:ea typeface="Calibri" pitchFamily="34" charset="-122"/>
+                <a:cs typeface="Calibri" pitchFamily="34" charset="-120"/>
+              </a:rPr>
+              <a:t>User / Client</a:t>
+            </a:r>
+            <a:endParaRPr lang="en-US" sz="950" dirty="0"/>
+          </a:p>
+        </p:txBody>
+      </p:sp>
+      <p:sp>
+        <p:nvSpPr>
+          <p:cNvPr id="18" name="Shape 15"/>
+          <p:cNvSpPr/>
+          <p:nvPr/>
+        </p:nvSpPr>
+        <p:spPr>
+          <a:xfrm>
+            <a:off x="329184" y="1673352"/>
+            <a:ext cx="1792224" cy="182880"/>
+          </a:xfrm>
+          <a:prstGeom prst="roundRect">
+            <a:avLst>
+              <a:gd name="adj" fmla="val 25000"/>
+            </a:avLst>
+          </a:prstGeom>
+          <a:solidFill>
+            <a:srgbClr val="BFDBFE"/>
+          </a:solidFill>
+          <a:ln w="8890">
+            <a:solidFill>
+              <a:srgbClr val="3B82F6"/>
+            </a:solidFill>
+            <a:prstDash val="solid"/>
+          </a:ln>
+        </p:spPr>
+      </p:sp>
+      <p:sp>
+        <p:nvSpPr>
+          <p:cNvPr id="19" name="Text 16"/>
+          <p:cNvSpPr/>
+          <p:nvPr/>
+        </p:nvSpPr>
+        <p:spPr>
+          <a:xfrm>
+            <a:off x="329184" y="1673352"/>
+            <a:ext cx="1792224" cy="182880"/>
+          </a:xfrm>
+          <a:prstGeom prst="rect">
+            <a:avLst/>
+          </a:prstGeom>
+          <a:noFill/>
+          <a:ln/>
+        </p:spPr>
+        <p:txBody>
+          <a:bodyPr wrap="square" lIns="12700" tIns="12700" rIns="12700" bIns="12700" rtlCol="0" anchor="ctr"/>
+          <a:lstStyle/>
+          <a:p>
+            <a:pPr algn="ctr" indent="0" marL="0">
+              <a:buNone/>
+            </a:pPr>
+            <a:r>
+              <a:rPr lang="en-US" sz="650" i="1" dirty="0">
+                <a:solidFill>
+                  <a:srgbClr val="1E40AF"/>
+                </a:solidFill>
+                <a:latin typeface="Calibri" pitchFamily="34" charset="0"/>
+                <a:ea typeface="Calibri" pitchFamily="34" charset="-122"/>
+                <a:cs typeface="Calibri" pitchFamily="34" charset="-120"/>
+              </a:rPr>
+              <a:t>Web Browser, REST client, HTML5 File API</a:t>
+            </a:r>
+            <a:endParaRPr lang="en-US" sz="650" dirty="0"/>
+          </a:p>
+        </p:txBody>
+      </p:sp>
+      <p:sp>
+        <p:nvSpPr>
+          <p:cNvPr id="20" name="Shape 17"/>
+          <p:cNvSpPr/>
+          <p:nvPr/>
+        </p:nvSpPr>
+        <p:spPr>
+          <a:xfrm>
+            <a:off x="256032" y="4142232"/>
+            <a:ext cx="1938528" cy="621792"/>
+          </a:xfrm>
+          <a:prstGeom prst="roundRect">
+            <a:avLst>
+              <a:gd name="adj" fmla="val 7353"/>
+            </a:avLst>
+          </a:prstGeom>
+          <a:solidFill>
+            <a:srgbClr val="DBEAFE"/>
+          </a:solidFill>
+          <a:ln w="22860">
+            <a:solidFill>
+              <a:srgbClr val="3B82F6"/>
+            </a:solidFill>
+            <a:prstDash val="solid"/>
+          </a:ln>
+        </p:spPr>
+      </p:sp>
+      <p:sp>
+        <p:nvSpPr>
+          <p:cNvPr id="21" name="Shape 18"/>
+          <p:cNvSpPr/>
+          <p:nvPr/>
+        </p:nvSpPr>
+        <p:spPr>
+          <a:xfrm>
+            <a:off x="347472" y="4142232"/>
+            <a:ext cx="1755648" cy="50292"/>
+          </a:xfrm>
+          <a:prstGeom prst="rect">
+            <a:avLst/>
+          </a:prstGeom>
+          <a:solidFill>
+            <a:srgbClr val="3B82F6"/>
+          </a:solidFill>
+          <a:ln w="1270">
+            <a:solidFill>
+              <a:srgbClr val="3B82F6"/>
+            </a:solidFill>
+            <a:prstDash val="solid"/>
+          </a:ln>
+        </p:spPr>
+      </p:sp>
+      <p:sp>
+        <p:nvSpPr>
+          <p:cNvPr id="22" name="Text 19"/>
+          <p:cNvSpPr/>
+          <p:nvPr/>
+        </p:nvSpPr>
+        <p:spPr>
+          <a:xfrm>
+            <a:off x="310896" y="4192524"/>
+            <a:ext cx="1828800" cy="297180"/>
+          </a:xfrm>
+          <a:prstGeom prst="rect">
+            <a:avLst/>
+          </a:prstGeom>
+          <a:noFill/>
+          <a:ln/>
+        </p:spPr>
+        <p:txBody>
+          <a:bodyPr wrap="square" lIns="0" tIns="0" rIns="0" bIns="0" rtlCol="0" anchor="ctr"/>
+          <a:lstStyle/>
+          <a:p>
+            <a:pPr algn="ctr" indent="0" marL="0">
+              <a:buNone/>
+            </a:pPr>
+            <a:r>
+              <a:rPr lang="en-US" sz="950" b="1" dirty="0">
+                <a:solidFill>
+                  <a:srgbClr val="1E3A8A"/>
+                </a:solidFill>
+                <a:latin typeface="Calibri" pitchFamily="34" charset="0"/>
+                <a:ea typeface="Calibri" pitchFamily="34" charset="-122"/>
+                <a:cs typeface="Calibri" pitchFamily="34" charset="-120"/>
+              </a:rPr>
+              <a:t>Azure AI Foundry</a:t>
+            </a:r>
+            <a:endParaRPr lang="en-US" sz="950" dirty="0"/>
+          </a:p>
+        </p:txBody>
+      </p:sp>
+      <p:sp>
+        <p:nvSpPr>
+          <p:cNvPr id="23" name="Shape 20"/>
+          <p:cNvSpPr/>
+          <p:nvPr/>
+        </p:nvSpPr>
+        <p:spPr>
+          <a:xfrm>
+            <a:off x="329184" y="4535424"/>
+            <a:ext cx="1792224" cy="182880"/>
+          </a:xfrm>
+          <a:prstGeom prst="roundRect">
+            <a:avLst>
+              <a:gd name="adj" fmla="val 25000"/>
+            </a:avLst>
+          </a:prstGeom>
+          <a:solidFill>
+            <a:srgbClr val="BFDBFE"/>
+          </a:solidFill>
+          <a:ln w="8890">
+            <a:solidFill>
+              <a:srgbClr val="3B82F6"/>
+            </a:solidFill>
+            <a:prstDash val="solid"/>
+          </a:ln>
+        </p:spPr>
+      </p:sp>
+      <p:sp>
+        <p:nvSpPr>
+          <p:cNvPr id="24" name="Text 21"/>
+          <p:cNvSpPr/>
+          <p:nvPr/>
+        </p:nvSpPr>
+        <p:spPr>
+          <a:xfrm>
+            <a:off x="329184" y="4535424"/>
+            <a:ext cx="1792224" cy="182880"/>
+          </a:xfrm>
+          <a:prstGeom prst="rect">
+            <a:avLst/>
+          </a:prstGeom>
+          <a:noFill/>
+          <a:ln/>
+        </p:spPr>
+        <p:txBody>
+          <a:bodyPr wrap="square" lIns="12700" tIns="12700" rIns="12700" bIns="12700" rtlCol="0" anchor="ctr"/>
+          <a:lstStyle/>
+          <a:p>
+            <a:pPr algn="ctr" indent="0" marL="0">
+              <a:buNone/>
+            </a:pPr>
+            <a:r>
+              <a:rPr lang="en-US" sz="650" i="1" dirty="0">
+                <a:solidFill>
+                  <a:srgbClr val="1E40AF"/>
+                </a:solidFill>
+                <a:latin typeface="Calibri" pitchFamily="34" charset="0"/>
+                <a:ea typeface="Calibri" pitchFamily="34" charset="-122"/>
+                <a:cs typeface="Calibri" pitchFamily="34" charset="-120"/>
+              </a:rPr>
+              <a:t>Azure AI Foundry, AzureOpenAI client, Meta Llama 3.3</a:t>
+            </a:r>
+            <a:endParaRPr lang="en-US" sz="650" dirty="0"/>
+          </a:p>
+        </p:txBody>
+      </p:sp>
+      <p:sp>
+        <p:nvSpPr>
+          <p:cNvPr id="25" name="Shape 22"/>
+          <p:cNvSpPr/>
+          <p:nvPr/>
+        </p:nvSpPr>
+        <p:spPr>
+          <a:xfrm>
+            <a:off x="2395728" y="749808"/>
+            <a:ext cx="2121408" cy="4160520"/>
+          </a:xfrm>
+          <a:prstGeom prst="roundRect">
+            <a:avLst>
+              <a:gd name="adj" fmla="val 2155"/>
+            </a:avLst>
+          </a:prstGeom>
+          <a:solidFill>
+            <a:srgbClr val="F8FAFC"/>
+          </a:solidFill>
+          <a:ln w="12700">
+            <a:solidFill>
+              <a:srgbClr val="8B5CF6"/>
+            </a:solidFill>
+            <a:prstDash val="solid"/>
+          </a:ln>
+        </p:spPr>
+      </p:sp>
+      <p:sp>
+        <p:nvSpPr>
+          <p:cNvPr id="26" name="Shape 23"/>
+          <p:cNvSpPr/>
+          <p:nvPr/>
+        </p:nvSpPr>
+        <p:spPr>
+          <a:xfrm>
+            <a:off x="2395728" y="749808"/>
+            <a:ext cx="2121408" cy="384048"/>
+          </a:xfrm>
+          <a:prstGeom prst="roundRect">
+            <a:avLst>
+              <a:gd name="adj" fmla="val 11905"/>
+            </a:avLst>
+          </a:prstGeom>
+          <a:solidFill>
+            <a:srgbClr val="6D28D9"/>
+          </a:solidFill>
+          <a:ln w="1270">
+            <a:solidFill>
+              <a:srgbClr val="6D28D9"/>
+            </a:solidFill>
+            <a:prstDash val="solid"/>
+          </a:ln>
+        </p:spPr>
+      </p:sp>
+      <p:sp>
+        <p:nvSpPr>
+          <p:cNvPr id="27" name="Shape 24"/>
+          <p:cNvSpPr/>
+          <p:nvPr/>
+        </p:nvSpPr>
+        <p:spPr>
+          <a:xfrm>
+            <a:off x="2395728" y="941832"/>
+            <a:ext cx="2121408" cy="192024"/>
+          </a:xfrm>
+          <a:prstGeom prst="rect">
+            <a:avLst/>
+          </a:prstGeom>
+          <a:solidFill>
+            <a:srgbClr val="6D28D9"/>
+          </a:solidFill>
+          <a:ln w="1270">
+            <a:solidFill>
+              <a:srgbClr val="6D28D9"/>
+            </a:solidFill>
+            <a:prstDash val="solid"/>
+          </a:ln>
+        </p:spPr>
+      </p:sp>
+      <p:sp>
+        <p:nvSpPr>
+          <p:cNvPr id="28" name="Text 25"/>
+          <p:cNvSpPr/>
+          <p:nvPr/>
+        </p:nvSpPr>
+        <p:spPr>
+          <a:xfrm>
+            <a:off x="2395728" y="749808"/>
+            <a:ext cx="2121408" cy="384048"/>
+          </a:xfrm>
+          <a:prstGeom prst="rect">
+            <a:avLst/>
+          </a:prstGeom>
+          <a:noFill/>
+          <a:ln/>
+        </p:spPr>
+        <p:txBody>
+          <a:bodyPr wrap="square" lIns="0" tIns="0" rIns="0" bIns="0" rtlCol="0" anchor="ctr"/>
+          <a:lstStyle/>
+          <a:p>
+            <a:pPr algn="ctr" indent="0" marL="0">
+              <a:buNone/>
+            </a:pPr>
+            <a:r>
+              <a:rPr lang="en-US" sz="850" b="1" dirty="0">
+                <a:solidFill>
+                  <a:srgbClr val="FFFFFF"/>
+                </a:solidFill>
+                <a:latin typeface="Calibri" pitchFamily="34" charset="0"/>
+                <a:ea typeface="Calibri" pitchFamily="34" charset="-122"/>
+                <a:cs typeface="Calibri" pitchFamily="34" charset="-120"/>
+              </a:rPr>
+              <a:t>FRONTEND</a:t>
+            </a:r>
+            <a:endParaRPr lang="en-US" sz="850" dirty="0"/>
+          </a:p>
+        </p:txBody>
+      </p:sp>
+      <p:sp>
+        <p:nvSpPr>
+          <p:cNvPr id="29" name="Shape 26"/>
+          <p:cNvSpPr/>
+          <p:nvPr/>
+        </p:nvSpPr>
+        <p:spPr>
+          <a:xfrm>
+            <a:off x="2487168" y="2711196"/>
+            <a:ext cx="1938528" cy="621792"/>
+          </a:xfrm>
+          <a:prstGeom prst="roundRect">
+            <a:avLst>
+              <a:gd name="adj" fmla="val 7353"/>
+            </a:avLst>
+          </a:prstGeom>
+          <a:solidFill>
+            <a:srgbClr val="EDE9FE"/>
+          </a:solidFill>
+          <a:ln w="22860">
+            <a:solidFill>
+              <a:srgbClr val="8B5CF6"/>
+            </a:solidFill>
+            <a:prstDash val="solid"/>
+          </a:ln>
+        </p:spPr>
+      </p:sp>
+      <p:sp>
+        <p:nvSpPr>
+          <p:cNvPr id="30" name="Shape 27"/>
+          <p:cNvSpPr/>
+          <p:nvPr/>
+        </p:nvSpPr>
+        <p:spPr>
+          <a:xfrm>
+            <a:off x="2578608" y="2711196"/>
+            <a:ext cx="1755648" cy="50292"/>
+          </a:xfrm>
+          <a:prstGeom prst="rect">
+            <a:avLst/>
+          </a:prstGeom>
+          <a:solidFill>
+            <a:srgbClr val="8B5CF6"/>
+          </a:solidFill>
+          <a:ln w="1270">
+            <a:solidFill>
+              <a:srgbClr val="8B5CF6"/>
+            </a:solidFill>
+            <a:prstDash val="solid"/>
+          </a:ln>
+        </p:spPr>
+      </p:sp>
+      <p:sp>
+        <p:nvSpPr>
+          <p:cNvPr id="31" name="Text 28"/>
+          <p:cNvSpPr/>
+          <p:nvPr/>
+        </p:nvSpPr>
+        <p:spPr>
+          <a:xfrm>
+            <a:off x="2542032" y="2761488"/>
+            <a:ext cx="1828800" cy="297180"/>
+          </a:xfrm>
+          <a:prstGeom prst="rect">
+            <a:avLst/>
+          </a:prstGeom>
+          <a:noFill/>
+          <a:ln/>
+        </p:spPr>
+        <p:txBody>
+          <a:bodyPr wrap="square" lIns="0" tIns="0" rIns="0" bIns="0" rtlCol="0" anchor="ctr"/>
+          <a:lstStyle/>
+          <a:p>
+            <a:pPr algn="ctr" indent="0" marL="0">
+              <a:buNone/>
+            </a:pPr>
+            <a:r>
+              <a:rPr lang="en-US" sz="950" b="1" dirty="0">
+                <a:solidFill>
+                  <a:srgbClr val="4C1D95"/>
+                </a:solidFill>
+                <a:latin typeface="Calibri" pitchFamily="34" charset="0"/>
+                <a:ea typeface="Calibri" pitchFamily="34" charset="-122"/>
+                <a:cs typeface="Calibri" pitchFamily="34" charset="-120"/>
+              </a:rPr>
+              <a:t>SPA Frontend</a:t>
+            </a:r>
+            <a:endParaRPr lang="en-US" sz="950" dirty="0"/>
+          </a:p>
+        </p:txBody>
+      </p:sp>
+      <p:sp>
+        <p:nvSpPr>
+          <p:cNvPr id="32" name="Shape 29"/>
+          <p:cNvSpPr/>
+          <p:nvPr/>
+        </p:nvSpPr>
+        <p:spPr>
+          <a:xfrm>
+            <a:off x="2560320" y="3104388"/>
+            <a:ext cx="1792224" cy="182880"/>
+          </a:xfrm>
+          <a:prstGeom prst="roundRect">
+            <a:avLst>
+              <a:gd name="adj" fmla="val 25000"/>
+            </a:avLst>
+          </a:prstGeom>
+          <a:solidFill>
+            <a:srgbClr val="DDD6FE"/>
+          </a:solidFill>
+          <a:ln w="8890">
+            <a:solidFill>
+              <a:srgbClr val="8B5CF6"/>
+            </a:solidFill>
+            <a:prstDash val="solid"/>
+          </a:ln>
+        </p:spPr>
+      </p:sp>
+      <p:sp>
+        <p:nvSpPr>
+          <p:cNvPr id="33" name="Text 30"/>
+          <p:cNvSpPr/>
+          <p:nvPr/>
+        </p:nvSpPr>
+        <p:spPr>
+          <a:xfrm>
+            <a:off x="2560320" y="3104388"/>
+            <a:ext cx="1792224" cy="182880"/>
+          </a:xfrm>
+          <a:prstGeom prst="rect">
+            <a:avLst/>
+          </a:prstGeom>
+          <a:noFill/>
+          <a:ln/>
+        </p:spPr>
+        <p:txBody>
+          <a:bodyPr wrap="square" lIns="12700" tIns="12700" rIns="12700" bIns="12700" rtlCol="0" anchor="ctr"/>
+          <a:lstStyle/>
+          <a:p>
+            <a:pPr algn="ctr" indent="0" marL="0">
+              <a:buNone/>
+            </a:pPr>
+            <a:r>
+              <a:rPr lang="en-US" sz="650" i="1" dirty="0">
+                <a:solidFill>
+                  <a:srgbClr val="5B21B6"/>
+                </a:solidFill>
+                <a:latin typeface="Calibri" pitchFamily="34" charset="0"/>
+                <a:ea typeface="Calibri" pitchFamily="34" charset="-122"/>
+                <a:cs typeface="Calibri" pitchFamily="34" charset="-120"/>
+              </a:rPr>
+              <a:t>Bootstrap 5.3.3, HTML5, CSS3, JavaScript, Purple des</a:t>
+            </a:r>
+            <a:endParaRPr lang="en-US" sz="650" dirty="0"/>
+          </a:p>
+        </p:txBody>
+      </p:sp>
+      <p:sp>
+        <p:nvSpPr>
+          <p:cNvPr id="34" name="Shape 31"/>
+          <p:cNvSpPr/>
+          <p:nvPr/>
+        </p:nvSpPr>
+        <p:spPr>
+          <a:xfrm>
+            <a:off x="4626864" y="749808"/>
+            <a:ext cx="2121408" cy="4160520"/>
+          </a:xfrm>
+          <a:prstGeom prst="roundRect">
+            <a:avLst>
+              <a:gd name="adj" fmla="val 2155"/>
+            </a:avLst>
+          </a:prstGeom>
+          <a:solidFill>
+            <a:srgbClr val="F8FAFC"/>
+          </a:solidFill>
+          <a:ln w="12700">
+            <a:solidFill>
+              <a:srgbClr val="10B981"/>
+            </a:solidFill>
+            <a:prstDash val="solid"/>
+          </a:ln>
+        </p:spPr>
+      </p:sp>
+      <p:sp>
+        <p:nvSpPr>
+          <p:cNvPr id="35" name="Shape 32"/>
+          <p:cNvSpPr/>
+          <p:nvPr/>
+        </p:nvSpPr>
+        <p:spPr>
+          <a:xfrm>
+            <a:off x="4626864" y="749808"/>
+            <a:ext cx="2121408" cy="384048"/>
+          </a:xfrm>
+          <a:prstGeom prst="roundRect">
+            <a:avLst>
+              <a:gd name="adj" fmla="val 11905"/>
+            </a:avLst>
+          </a:prstGeom>
+          <a:solidFill>
+            <a:srgbClr val="065F46"/>
+          </a:solidFill>
+          <a:ln w="1270">
+            <a:solidFill>
+              <a:srgbClr val="065F46"/>
+            </a:solidFill>
+            <a:prstDash val="solid"/>
+          </a:ln>
+        </p:spPr>
+      </p:sp>
+      <p:sp>
+        <p:nvSpPr>
+          <p:cNvPr id="36" name="Shape 33"/>
+          <p:cNvSpPr/>
+          <p:nvPr/>
+        </p:nvSpPr>
+        <p:spPr>
+          <a:xfrm>
+            <a:off x="4626864" y="941832"/>
+            <a:ext cx="2121408" cy="192024"/>
+          </a:xfrm>
+          <a:prstGeom prst="rect">
+            <a:avLst/>
+          </a:prstGeom>
+          <a:solidFill>
+            <a:srgbClr val="065F46"/>
+          </a:solidFill>
+          <a:ln w="1270">
+            <a:solidFill>
+              <a:srgbClr val="065F46"/>
+            </a:solidFill>
+            <a:prstDash val="solid"/>
+          </a:ln>
+        </p:spPr>
+      </p:sp>
+      <p:sp>
+        <p:nvSpPr>
+          <p:cNvPr id="37" name="Text 34"/>
+          <p:cNvSpPr/>
+          <p:nvPr/>
+        </p:nvSpPr>
+        <p:spPr>
+          <a:xfrm>
+            <a:off x="4626864" y="749808"/>
+            <a:ext cx="2121408" cy="384048"/>
+          </a:xfrm>
+          <a:prstGeom prst="rect">
+            <a:avLst/>
+          </a:prstGeom>
+          <a:noFill/>
+          <a:ln/>
+        </p:spPr>
+        <p:txBody>
+          <a:bodyPr wrap="square" lIns="0" tIns="0" rIns="0" bIns="0" rtlCol="0" anchor="ctr"/>
+          <a:lstStyle/>
+          <a:p>
+            <a:pPr algn="ctr" indent="0" marL="0">
+              <a:buNone/>
+            </a:pPr>
+            <a:r>
+              <a:rPr lang="en-US" sz="850" b="1" dirty="0">
+                <a:solidFill>
+                  <a:srgbClr val="FFFFFF"/>
+                </a:solidFill>
+                <a:latin typeface="Calibri" pitchFamily="34" charset="0"/>
+                <a:ea typeface="Calibri" pitchFamily="34" charset="-122"/>
+                <a:cs typeface="Calibri" pitchFamily="34" charset="-120"/>
+              </a:rPr>
+              <a:t>BACKEND</a:t>
+            </a:r>
+            <a:endParaRPr lang="en-US" sz="850" dirty="0"/>
+          </a:p>
+        </p:txBody>
+      </p:sp>
+      <p:sp>
+        <p:nvSpPr>
+          <p:cNvPr id="38" name="Shape 35"/>
+          <p:cNvSpPr/>
+          <p:nvPr/>
+        </p:nvSpPr>
+        <p:spPr>
+          <a:xfrm>
+            <a:off x="4718304" y="1280160"/>
+            <a:ext cx="1938528" cy="621792"/>
+          </a:xfrm>
+          <a:prstGeom prst="roundRect">
+            <a:avLst>
+              <a:gd name="adj" fmla="val 7353"/>
+            </a:avLst>
+          </a:prstGeom>
+          <a:solidFill>
+            <a:srgbClr val="D1FAE5"/>
+          </a:solidFill>
+          <a:ln w="22860">
+            <a:solidFill>
+              <a:srgbClr val="10B981"/>
+            </a:solidFill>
+            <a:prstDash val="solid"/>
+          </a:ln>
+        </p:spPr>
+      </p:sp>
+      <p:sp>
+        <p:nvSpPr>
+          <p:cNvPr id="39" name="Shape 36"/>
+          <p:cNvSpPr/>
+          <p:nvPr/>
+        </p:nvSpPr>
+        <p:spPr>
+          <a:xfrm>
+            <a:off x="4809744" y="1280160"/>
+            <a:ext cx="1755648" cy="50292"/>
+          </a:xfrm>
+          <a:prstGeom prst="rect">
+            <a:avLst/>
+          </a:prstGeom>
+          <a:solidFill>
+            <a:srgbClr val="10B981"/>
+          </a:solidFill>
+          <a:ln w="1270">
+            <a:solidFill>
+              <a:srgbClr val="10B981"/>
+            </a:solidFill>
+            <a:prstDash val="solid"/>
+          </a:ln>
+        </p:spPr>
+      </p:sp>
+      <p:sp>
+        <p:nvSpPr>
+          <p:cNvPr id="40" name="Text 37"/>
+          <p:cNvSpPr/>
+          <p:nvPr/>
+        </p:nvSpPr>
+        <p:spPr>
+          <a:xfrm>
+            <a:off x="4773168" y="1330452"/>
+            <a:ext cx="1828800" cy="297180"/>
+          </a:xfrm>
+          <a:prstGeom prst="rect">
+            <a:avLst/>
+          </a:prstGeom>
+          <a:noFill/>
+          <a:ln/>
+        </p:spPr>
+        <p:txBody>
+          <a:bodyPr wrap="square" lIns="0" tIns="0" rIns="0" bIns="0" rtlCol="0" anchor="ctr"/>
+          <a:lstStyle/>
+          <a:p>
+            <a:pPr algn="ctr" indent="0" marL="0">
+              <a:buNone/>
+            </a:pPr>
+            <a:r>
+              <a:rPr lang="en-US" sz="950" b="1" dirty="0">
+                <a:solidFill>
+                  <a:srgbClr val="064E3B"/>
+                </a:solidFill>
+                <a:latin typeface="Calibri" pitchFamily="34" charset="0"/>
+                <a:ea typeface="Calibri" pitchFamily="34" charset="-122"/>
+                <a:cs typeface="Calibri" pitchFamily="34" charset="-120"/>
+              </a:rPr>
+              <a:t>Python Pipeline</a:t>
+            </a:r>
+            <a:endParaRPr lang="en-US" sz="950" dirty="0"/>
+          </a:p>
+        </p:txBody>
+      </p:sp>
+      <p:sp>
+        <p:nvSpPr>
+          <p:cNvPr id="41" name="Shape 38"/>
+          <p:cNvSpPr/>
+          <p:nvPr/>
+        </p:nvSpPr>
+        <p:spPr>
+          <a:xfrm>
+            <a:off x="4791456" y="1673352"/>
+            <a:ext cx="1792224" cy="182880"/>
+          </a:xfrm>
+          <a:prstGeom prst="roundRect">
+            <a:avLst>
+              <a:gd name="adj" fmla="val 25000"/>
+            </a:avLst>
+          </a:prstGeom>
+          <a:solidFill>
+            <a:srgbClr val="A7F3D0"/>
+          </a:solidFill>
+          <a:ln w="8890">
+            <a:solidFill>
+              <a:srgbClr val="10B981"/>
+            </a:solidFill>
+            <a:prstDash val="solid"/>
+          </a:ln>
+        </p:spPr>
+      </p:sp>
+      <p:sp>
+        <p:nvSpPr>
+          <p:cNvPr id="42" name="Text 39"/>
+          <p:cNvSpPr/>
+          <p:nvPr/>
+        </p:nvSpPr>
+        <p:spPr>
+          <a:xfrm>
+            <a:off x="4791456" y="1673352"/>
+            <a:ext cx="1792224" cy="182880"/>
+          </a:xfrm>
+          <a:prstGeom prst="rect">
+            <a:avLst/>
+          </a:prstGeom>
+          <a:noFill/>
+          <a:ln/>
+        </p:spPr>
+        <p:txBody>
+          <a:bodyPr wrap="square" lIns="12700" tIns="12700" rIns="12700" bIns="12700" rtlCol="0" anchor="ctr"/>
+          <a:lstStyle/>
+          <a:p>
+            <a:pPr algn="ctr" indent="0" marL="0">
+              <a:buNone/>
+            </a:pPr>
+            <a:r>
+              <a:rPr lang="en-US" sz="650" i="1" dirty="0">
+                <a:solidFill>
+                  <a:srgbClr val="065F46"/>
+                </a:solidFill>
+                <a:latin typeface="Calibri" pitchFamily="34" charset="0"/>
+                <a:ea typeface="Calibri" pitchFamily="34" charset="-122"/>
+                <a:cs typeface="Calibri" pitchFamily="34" charset="-120"/>
+              </a:rPr>
+              <a:t>Python, server.py, Pandas, openpyxl</a:t>
+            </a:r>
+            <a:endParaRPr lang="en-US" sz="650" dirty="0"/>
+          </a:p>
+        </p:txBody>
+      </p:sp>
+      <p:sp>
+        <p:nvSpPr>
+          <p:cNvPr id="43" name="Shape 40"/>
+          <p:cNvSpPr/>
+          <p:nvPr/>
+        </p:nvSpPr>
+        <p:spPr>
+          <a:xfrm>
+            <a:off x="4718304" y="2234184"/>
+            <a:ext cx="1938528" cy="621792"/>
+          </a:xfrm>
+          <a:prstGeom prst="roundRect">
+            <a:avLst>
+              <a:gd name="adj" fmla="val 7353"/>
+            </a:avLst>
+          </a:prstGeom>
+          <a:solidFill>
+            <a:srgbClr val="D1FAE5"/>
+          </a:solidFill>
+          <a:ln w="22860">
+            <a:solidFill>
+              <a:srgbClr val="10B981"/>
+            </a:solidFill>
+            <a:prstDash val="solid"/>
+          </a:ln>
+        </p:spPr>
+      </p:sp>
+      <p:sp>
+        <p:nvSpPr>
+          <p:cNvPr id="44" name="Shape 41"/>
+          <p:cNvSpPr/>
+          <p:nvPr/>
+        </p:nvSpPr>
+        <p:spPr>
+          <a:xfrm>
+            <a:off x="4809744" y="2234184"/>
+            <a:ext cx="1755648" cy="50292"/>
+          </a:xfrm>
+          <a:prstGeom prst="rect">
+            <a:avLst/>
+          </a:prstGeom>
+          <a:solidFill>
+            <a:srgbClr val="10B981"/>
+          </a:solidFill>
+          <a:ln w="1270">
+            <a:solidFill>
+              <a:srgbClr val="10B981"/>
+            </a:solidFill>
+            <a:prstDash val="solid"/>
+          </a:ln>
+        </p:spPr>
+      </p:sp>
+      <p:sp>
+        <p:nvSpPr>
+          <p:cNvPr id="45" name="Text 42"/>
+          <p:cNvSpPr/>
+          <p:nvPr/>
+        </p:nvSpPr>
+        <p:spPr>
+          <a:xfrm>
+            <a:off x="4773168" y="2284476"/>
+            <a:ext cx="1828800" cy="297180"/>
+          </a:xfrm>
+          <a:prstGeom prst="rect">
+            <a:avLst/>
+          </a:prstGeom>
+          <a:noFill/>
+          <a:ln/>
+        </p:spPr>
+        <p:txBody>
+          <a:bodyPr wrap="square" lIns="0" tIns="0" rIns="0" bIns="0" rtlCol="0" anchor="ctr"/>
+          <a:lstStyle/>
+          <a:p>
+            <a:pPr algn="ctr" indent="0" marL="0">
+              <a:buNone/>
+            </a:pPr>
+            <a:r>
+              <a:rPr lang="en-US" sz="950" b="1" dirty="0">
+                <a:solidFill>
+                  <a:srgbClr val="064E3B"/>
+                </a:solidFill>
+                <a:latin typeface="Calibri" pitchFamily="34" charset="0"/>
+                <a:ea typeface="Calibri" pitchFamily="34" charset="-122"/>
+                <a:cs typeface="Calibri" pitchFamily="34" charset="-120"/>
+              </a:rPr>
+              <a:t>Input Sanitiser</a:t>
+            </a:r>
+            <a:endParaRPr lang="en-US" sz="950" dirty="0"/>
+          </a:p>
+        </p:txBody>
+      </p:sp>
+      <p:sp>
+        <p:nvSpPr>
+          <p:cNvPr id="46" name="Shape 43"/>
+          <p:cNvSpPr/>
+          <p:nvPr/>
+        </p:nvSpPr>
+        <p:spPr>
+          <a:xfrm>
+            <a:off x="4791456" y="2627376"/>
+            <a:ext cx="1792224" cy="182880"/>
+          </a:xfrm>
+          <a:prstGeom prst="roundRect">
+            <a:avLst>
+              <a:gd name="adj" fmla="val 25000"/>
+            </a:avLst>
+          </a:prstGeom>
+          <a:solidFill>
+            <a:srgbClr val="A7F3D0"/>
+          </a:solidFill>
+          <a:ln w="8890">
+            <a:solidFill>
+              <a:srgbClr val="10B981"/>
+            </a:solidFill>
+            <a:prstDash val="solid"/>
+          </a:ln>
+        </p:spPr>
+      </p:sp>
+      <p:sp>
+        <p:nvSpPr>
+          <p:cNvPr id="47" name="Text 44"/>
+          <p:cNvSpPr/>
+          <p:nvPr/>
+        </p:nvSpPr>
+        <p:spPr>
+          <a:xfrm>
+            <a:off x="4791456" y="2627376"/>
+            <a:ext cx="1792224" cy="182880"/>
+          </a:xfrm>
+          <a:prstGeom prst="rect">
+            <a:avLst/>
+          </a:prstGeom>
+          <a:noFill/>
+          <a:ln/>
+        </p:spPr>
+        <p:txBody>
+          <a:bodyPr wrap="square" lIns="12700" tIns="12700" rIns="12700" bIns="12700" rtlCol="0" anchor="ctr"/>
+          <a:lstStyle/>
+          <a:p>
+            <a:pPr algn="ctr" indent="0" marL="0">
+              <a:buNone/>
+            </a:pPr>
+            <a:r>
+              <a:rPr lang="en-US" sz="650" i="1" dirty="0">
+                <a:solidFill>
+                  <a:srgbClr val="065F46"/>
+                </a:solidFill>
+                <a:latin typeface="Calibri" pitchFamily="34" charset="0"/>
+                <a:ea typeface="Calibri" pitchFamily="34" charset="-122"/>
+                <a:cs typeface="Calibri" pitchFamily="34" charset="-120"/>
+              </a:rPr>
+              <a:t>Python unicodedata, str.strip, str.lower</a:t>
+            </a:r>
+            <a:endParaRPr lang="en-US" sz="650" dirty="0"/>
+          </a:p>
+        </p:txBody>
+      </p:sp>
+      <p:sp>
+        <p:nvSpPr>
+          <p:cNvPr id="48" name="Shape 45"/>
+          <p:cNvSpPr/>
+          <p:nvPr/>
+        </p:nvSpPr>
+        <p:spPr>
+          <a:xfrm>
+            <a:off x="4718304" y="3188208"/>
+            <a:ext cx="1938528" cy="621792"/>
+          </a:xfrm>
+          <a:prstGeom prst="roundRect">
+            <a:avLst>
+              <a:gd name="adj" fmla="val 7353"/>
+            </a:avLst>
+          </a:prstGeom>
+          <a:solidFill>
+            <a:srgbClr val="D1FAE5"/>
+          </a:solidFill>
+          <a:ln w="22860">
+            <a:solidFill>
+              <a:srgbClr val="10B981"/>
+            </a:solidFill>
+            <a:prstDash val="solid"/>
+          </a:ln>
+        </p:spPr>
+      </p:sp>
+      <p:sp>
+        <p:nvSpPr>
+          <p:cNvPr id="49" name="Shape 46"/>
+          <p:cNvSpPr/>
+          <p:nvPr/>
+        </p:nvSpPr>
+        <p:spPr>
+          <a:xfrm>
+            <a:off x="4809744" y="3188208"/>
+            <a:ext cx="1755648" cy="50292"/>
+          </a:xfrm>
+          <a:prstGeom prst="rect">
+            <a:avLst/>
+          </a:prstGeom>
+          <a:solidFill>
+            <a:srgbClr val="10B981"/>
+          </a:solidFill>
+          <a:ln w="1270">
+            <a:solidFill>
+              <a:srgbClr val="10B981"/>
+            </a:solidFill>
+            <a:prstDash val="solid"/>
+          </a:ln>
+        </p:spPr>
+      </p:sp>
+      <p:sp>
+        <p:nvSpPr>
+          <p:cNvPr id="50" name="Text 47"/>
+          <p:cNvSpPr/>
+          <p:nvPr/>
+        </p:nvSpPr>
+        <p:spPr>
+          <a:xfrm>
+            <a:off x="4773168" y="3238500"/>
+            <a:ext cx="1828800" cy="297180"/>
+          </a:xfrm>
+          <a:prstGeom prst="rect">
+            <a:avLst/>
+          </a:prstGeom>
+          <a:noFill/>
+          <a:ln/>
+        </p:spPr>
+        <p:txBody>
+          <a:bodyPr wrap="square" lIns="0" tIns="0" rIns="0" bIns="0" rtlCol="0" anchor="ctr"/>
+          <a:lstStyle/>
+          <a:p>
+            <a:pPr algn="ctr" indent="0" marL="0">
+              <a:buNone/>
+            </a:pPr>
+            <a:r>
+              <a:rPr lang="en-US" sz="950" b="1" dirty="0">
+                <a:solidFill>
+                  <a:srgbClr val="064E3B"/>
+                </a:solidFill>
+                <a:latin typeface="Calibri" pitchFamily="34" charset="0"/>
+                <a:ea typeface="Calibri" pitchFamily="34" charset="-122"/>
+                <a:cs typeface="Calibri" pitchFamily="34" charset="-120"/>
+              </a:rPr>
+              <a:t>Local Scorer</a:t>
+            </a:r>
+            <a:endParaRPr lang="en-US" sz="950" dirty="0"/>
+          </a:p>
+        </p:txBody>
+      </p:sp>
+      <p:sp>
+        <p:nvSpPr>
+          <p:cNvPr id="51" name="Shape 48"/>
+          <p:cNvSpPr/>
+          <p:nvPr/>
+        </p:nvSpPr>
+        <p:spPr>
+          <a:xfrm>
+            <a:off x="4791456" y="3581400"/>
+            <a:ext cx="1792224" cy="182880"/>
+          </a:xfrm>
+          <a:prstGeom prst="roundRect">
+            <a:avLst>
+              <a:gd name="adj" fmla="val 25000"/>
+            </a:avLst>
+          </a:prstGeom>
+          <a:solidFill>
+            <a:srgbClr val="A7F3D0"/>
+          </a:solidFill>
+          <a:ln w="8890">
+            <a:solidFill>
+              <a:srgbClr val="10B981"/>
+            </a:solidFill>
+            <a:prstDash val="solid"/>
+          </a:ln>
+        </p:spPr>
+      </p:sp>
+      <p:sp>
+        <p:nvSpPr>
+          <p:cNvPr id="52" name="Text 49"/>
+          <p:cNvSpPr/>
+          <p:nvPr/>
+        </p:nvSpPr>
+        <p:spPr>
+          <a:xfrm>
+            <a:off x="4791456" y="3581400"/>
+            <a:ext cx="1792224" cy="182880"/>
+          </a:xfrm>
+          <a:prstGeom prst="rect">
+            <a:avLst/>
+          </a:prstGeom>
+          <a:noFill/>
+          <a:ln/>
+        </p:spPr>
+        <p:txBody>
+          <a:bodyPr wrap="square" lIns="12700" tIns="12700" rIns="12700" bIns="12700" rtlCol="0" anchor="ctr"/>
+          <a:lstStyle/>
+          <a:p>
+            <a:pPr algn="ctr" indent="0" marL="0">
+              <a:buNone/>
+            </a:pPr>
+            <a:r>
+              <a:rPr lang="en-US" sz="650" i="1" dirty="0">
+                <a:solidFill>
+                  <a:srgbClr val="065F46"/>
+                </a:solidFill>
+                <a:latin typeface="Calibri" pitchFamily="34" charset="0"/>
+                <a:ea typeface="Calibri" pitchFamily="34" charset="-122"/>
+                <a:cs typeface="Calibri" pitchFamily="34" charset="-120"/>
+              </a:rPr>
+              <a:t>scikit-learn TF-IDF, character bi-gram to 4-gram, py</a:t>
+            </a:r>
+            <a:endParaRPr lang="en-US" sz="650" dirty="0"/>
+          </a:p>
+        </p:txBody>
+      </p:sp>
+      <p:sp>
+        <p:nvSpPr>
+          <p:cNvPr id="53" name="Shape 50"/>
+          <p:cNvSpPr/>
+          <p:nvPr/>
+        </p:nvSpPr>
+        <p:spPr>
+          <a:xfrm>
+            <a:off x="4718304" y="4142232"/>
+            <a:ext cx="1938528" cy="621792"/>
+          </a:xfrm>
+          <a:prstGeom prst="roundRect">
+            <a:avLst>
+              <a:gd name="adj" fmla="val 7353"/>
+            </a:avLst>
+          </a:prstGeom>
+          <a:solidFill>
+            <a:srgbClr val="D1FAE5"/>
+          </a:solidFill>
+          <a:ln w="22860">
+            <a:solidFill>
+              <a:srgbClr val="10B981"/>
+            </a:solidFill>
+            <a:prstDash val="solid"/>
+          </a:ln>
+        </p:spPr>
+      </p:sp>
+      <p:sp>
+        <p:nvSpPr>
+          <p:cNvPr id="54" name="Shape 51"/>
+          <p:cNvSpPr/>
+          <p:nvPr/>
+        </p:nvSpPr>
+        <p:spPr>
+          <a:xfrm>
+            <a:off x="4809744" y="4142232"/>
+            <a:ext cx="1755648" cy="50292"/>
+          </a:xfrm>
+          <a:prstGeom prst="rect">
+            <a:avLst/>
+          </a:prstGeom>
+          <a:solidFill>
+            <a:srgbClr val="10B981"/>
+          </a:solidFill>
+          <a:ln w="1270">
+            <a:solidFill>
+              <a:srgbClr val="10B981"/>
+            </a:solidFill>
+            <a:prstDash val="solid"/>
+          </a:ln>
+        </p:spPr>
+      </p:sp>
+      <p:sp>
+        <p:nvSpPr>
+          <p:cNvPr id="55" name="Text 52"/>
+          <p:cNvSpPr/>
+          <p:nvPr/>
+        </p:nvSpPr>
+        <p:spPr>
+          <a:xfrm>
+            <a:off x="4773168" y="4192524"/>
+            <a:ext cx="1828800" cy="297180"/>
+          </a:xfrm>
+          <a:prstGeom prst="rect">
+            <a:avLst/>
+          </a:prstGeom>
+          <a:noFill/>
+          <a:ln/>
+        </p:spPr>
+        <p:txBody>
+          <a:bodyPr wrap="square" lIns="0" tIns="0" rIns="0" bIns="0" rtlCol="0" anchor="ctr"/>
+          <a:lstStyle/>
+          <a:p>
+            <a:pPr algn="ctr" indent="0" marL="0">
+              <a:buNone/>
+            </a:pPr>
+            <a:r>
+              <a:rPr lang="en-US" sz="950" b="1" dirty="0">
+                <a:solidFill>
+                  <a:srgbClr val="064E3B"/>
+                </a:solidFill>
+                <a:latin typeface="Calibri" pitchFamily="34" charset="0"/>
+                <a:ea typeface="Calibri" pitchFamily="34" charset="-122"/>
+                <a:cs typeface="Calibri" pitchFamily="34" charset="-120"/>
+              </a:rPr>
+              <a:t>Report Generator</a:t>
+            </a:r>
+            <a:endParaRPr lang="en-US" sz="950" dirty="0"/>
+          </a:p>
+        </p:txBody>
+      </p:sp>
+      <p:sp>
+        <p:nvSpPr>
+          <p:cNvPr id="56" name="Shape 53"/>
+          <p:cNvSpPr/>
+          <p:nvPr/>
+        </p:nvSpPr>
+        <p:spPr>
+          <a:xfrm>
+            <a:off x="4791456" y="4535424"/>
+            <a:ext cx="1792224" cy="182880"/>
+          </a:xfrm>
+          <a:prstGeom prst="roundRect">
+            <a:avLst>
+              <a:gd name="adj" fmla="val 25000"/>
+            </a:avLst>
+          </a:prstGeom>
+          <a:solidFill>
+            <a:srgbClr val="A7F3D0"/>
+          </a:solidFill>
+          <a:ln w="8890">
+            <a:solidFill>
+              <a:srgbClr val="10B981"/>
+            </a:solidFill>
+            <a:prstDash val="solid"/>
+          </a:ln>
+        </p:spPr>
+      </p:sp>
+      <p:sp>
+        <p:nvSpPr>
+          <p:cNvPr id="57" name="Text 54"/>
+          <p:cNvSpPr/>
+          <p:nvPr/>
+        </p:nvSpPr>
+        <p:spPr>
+          <a:xfrm>
+            <a:off x="4791456" y="4535424"/>
+            <a:ext cx="1792224" cy="182880"/>
+          </a:xfrm>
+          <a:prstGeom prst="rect">
+            <a:avLst/>
+          </a:prstGeom>
+          <a:noFill/>
+          <a:ln/>
+        </p:spPr>
+        <p:txBody>
+          <a:bodyPr wrap="square" lIns="12700" tIns="12700" rIns="12700" bIns="12700" rtlCol="0" anchor="ctr"/>
+          <a:lstStyle/>
+          <a:p>
+            <a:pPr algn="ctr" indent="0" marL="0">
+              <a:buNone/>
+            </a:pPr>
+            <a:r>
+              <a:rPr lang="en-US" sz="650" i="1" dirty="0">
+                <a:solidFill>
+                  <a:srgbClr val="065F46"/>
+                </a:solidFill>
+                <a:latin typeface="Calibri" pitchFamily="34" charset="0"/>
+                <a:ea typeface="Calibri" pitchFamily="34" charset="-122"/>
+                <a:cs typeface="Calibri" pitchFamily="34" charset="-120"/>
+              </a:rPr>
+              <a:t>openpyxl, Pandas, Excel XLSX output</a:t>
+            </a:r>
+            <a:endParaRPr lang="en-US" sz="650" dirty="0"/>
+          </a:p>
+        </p:txBody>
+      </p:sp>
+      <p:sp>
+        <p:nvSpPr>
+          <p:cNvPr id="58" name="Shape 55"/>
+          <p:cNvSpPr/>
+          <p:nvPr/>
+        </p:nvSpPr>
+        <p:spPr>
+          <a:xfrm>
+            <a:off x="6858000" y="749808"/>
+            <a:ext cx="2121408" cy="4160520"/>
+          </a:xfrm>
+          <a:prstGeom prst="roundRect">
+            <a:avLst>
+              <a:gd name="adj" fmla="val 2155"/>
+            </a:avLst>
+          </a:prstGeom>
+          <a:solidFill>
+            <a:srgbClr val="F8FAFC"/>
+          </a:solidFill>
+          <a:ln w="12700">
+            <a:solidFill>
+              <a:srgbClr val="F59E0B"/>
+            </a:solidFill>
+            <a:prstDash val="solid"/>
+          </a:ln>
+        </p:spPr>
+      </p:sp>
+      <p:sp>
+        <p:nvSpPr>
+          <p:cNvPr id="59" name="Shape 56"/>
+          <p:cNvSpPr/>
+          <p:nvPr/>
+        </p:nvSpPr>
+        <p:spPr>
+          <a:xfrm>
+            <a:off x="6858000" y="749808"/>
+            <a:ext cx="2121408" cy="384048"/>
+          </a:xfrm>
+          <a:prstGeom prst="roundRect">
+            <a:avLst>
+              <a:gd name="adj" fmla="val 11905"/>
+            </a:avLst>
+          </a:prstGeom>
+          <a:solidFill>
+            <a:srgbClr val="92400E"/>
+          </a:solidFill>
+          <a:ln w="1270">
+            <a:solidFill>
+              <a:srgbClr val="92400E"/>
+            </a:solidFill>
+            <a:prstDash val="solid"/>
+          </a:ln>
+        </p:spPr>
+      </p:sp>
+      <p:sp>
+        <p:nvSpPr>
+          <p:cNvPr id="60" name="Shape 57"/>
+          <p:cNvSpPr/>
+          <p:nvPr/>
+        </p:nvSpPr>
+        <p:spPr>
+          <a:xfrm>
+            <a:off x="6858000" y="941832"/>
+            <a:ext cx="2121408" cy="192024"/>
+          </a:xfrm>
+          <a:prstGeom prst="rect">
+            <a:avLst/>
+          </a:prstGeom>
+          <a:solidFill>
+            <a:srgbClr val="92400E"/>
+          </a:solidFill>
+          <a:ln w="1270">
+            <a:solidFill>
+              <a:srgbClr val="92400E"/>
+            </a:solidFill>
+            <a:prstDash val="solid"/>
+          </a:ln>
+        </p:spPr>
+      </p:sp>
+      <p:sp>
+        <p:nvSpPr>
+          <p:cNvPr id="61" name="Text 58"/>
+          <p:cNvSpPr/>
+          <p:nvPr/>
+        </p:nvSpPr>
+        <p:spPr>
+          <a:xfrm>
+            <a:off x="6858000" y="749808"/>
+            <a:ext cx="2121408" cy="384048"/>
+          </a:xfrm>
+          <a:prstGeom prst="rect">
+            <a:avLst/>
+          </a:prstGeom>
+          <a:noFill/>
+          <a:ln/>
+        </p:spPr>
+        <p:txBody>
+          <a:bodyPr wrap="square" lIns="0" tIns="0" rIns="0" bIns="0" rtlCol="0" anchor="ctr"/>
+          <a:lstStyle/>
+          <a:p>
+            <a:pPr algn="ctr" indent="0" marL="0">
+              <a:buNone/>
+            </a:pPr>
+            <a:r>
+              <a:rPr lang="en-US" sz="850" b="1" dirty="0">
+                <a:solidFill>
+                  <a:srgbClr val="FFFFFF"/>
+                </a:solidFill>
+                <a:latin typeface="Calibri" pitchFamily="34" charset="0"/>
+                <a:ea typeface="Calibri" pitchFamily="34" charset="-122"/>
+                <a:cs typeface="Calibri" pitchFamily="34" charset="-120"/>
+              </a:rPr>
+              <a:t>AI/ML</a:t>
+            </a:r>
+            <a:endParaRPr lang="en-US" sz="850" dirty="0"/>
+          </a:p>
+        </p:txBody>
+      </p:sp>
+      <p:sp>
+        <p:nvSpPr>
+          <p:cNvPr id="62" name="Shape 59"/>
+          <p:cNvSpPr/>
+          <p:nvPr/>
+        </p:nvSpPr>
+        <p:spPr>
+          <a:xfrm>
+            <a:off x="6949440" y="2711196"/>
+            <a:ext cx="1938528" cy="621792"/>
+          </a:xfrm>
+          <a:prstGeom prst="roundRect">
+            <a:avLst>
+              <a:gd name="adj" fmla="val 7353"/>
+            </a:avLst>
+          </a:prstGeom>
+          <a:solidFill>
+            <a:srgbClr val="FEF3C7"/>
+          </a:solidFill>
+          <a:ln w="22860">
+            <a:solidFill>
+              <a:srgbClr val="F59E0B"/>
+            </a:solidFill>
+            <a:prstDash val="solid"/>
+          </a:ln>
+        </p:spPr>
+      </p:sp>
+      <p:sp>
+        <p:nvSpPr>
+          <p:cNvPr id="63" name="Shape 60"/>
+          <p:cNvSpPr/>
+          <p:nvPr/>
+        </p:nvSpPr>
+        <p:spPr>
+          <a:xfrm>
+            <a:off x="7040880" y="2711196"/>
+            <a:ext cx="1755648" cy="50292"/>
+          </a:xfrm>
+          <a:prstGeom prst="rect">
+            <a:avLst/>
+          </a:prstGeom>
+          <a:solidFill>
+            <a:srgbClr val="F59E0B"/>
+          </a:solidFill>
+          <a:ln w="1270">
+            <a:solidFill>
+              <a:srgbClr val="F59E0B"/>
+            </a:solidFill>
+            <a:prstDash val="solid"/>
+          </a:ln>
+        </p:spPr>
+      </p:sp>
+      <p:sp>
+        <p:nvSpPr>
+          <p:cNvPr id="64" name="Text 61"/>
+          <p:cNvSpPr/>
+          <p:nvPr/>
+        </p:nvSpPr>
+        <p:spPr>
+          <a:xfrm>
+            <a:off x="7004304" y="2761488"/>
+            <a:ext cx="1828800" cy="297180"/>
+          </a:xfrm>
+          <a:prstGeom prst="rect">
+            <a:avLst/>
+          </a:prstGeom>
+          <a:noFill/>
+          <a:ln/>
+        </p:spPr>
+        <p:txBody>
+          <a:bodyPr wrap="square" lIns="0" tIns="0" rIns="0" bIns="0" rtlCol="0" anchor="ctr"/>
+          <a:lstStyle/>
+          <a:p>
+            <a:pPr algn="ctr" indent="0" marL="0">
+              <a:buNone/>
+            </a:pPr>
+            <a:r>
+              <a:rPr lang="en-US" sz="950" b="1" dirty="0">
+                <a:solidFill>
+                  <a:srgbClr val="78350F"/>
+                </a:solidFill>
+                <a:latin typeface="Calibri" pitchFamily="34" charset="0"/>
+                <a:ea typeface="Calibri" pitchFamily="34" charset="-122"/>
+                <a:cs typeface="Calibri" pitchFamily="34" charset="-120"/>
+              </a:rPr>
+              <a:t>LLM Orchestrator</a:t>
+            </a:r>
+            <a:endParaRPr lang="en-US" sz="950" dirty="0"/>
+          </a:p>
+        </p:txBody>
+      </p:sp>
+      <p:sp>
+        <p:nvSpPr>
+          <p:cNvPr id="65" name="Shape 62"/>
+          <p:cNvSpPr/>
+          <p:nvPr/>
+        </p:nvSpPr>
+        <p:spPr>
+          <a:xfrm>
+            <a:off x="7022592" y="3104388"/>
+            <a:ext cx="1792224" cy="182880"/>
+          </a:xfrm>
+          <a:prstGeom prst="roundRect">
+            <a:avLst>
+              <a:gd name="adj" fmla="val 25000"/>
+            </a:avLst>
+          </a:prstGeom>
+          <a:solidFill>
+            <a:srgbClr val="FDE68A"/>
+          </a:solidFill>
+          <a:ln w="8890">
+            <a:solidFill>
+              <a:srgbClr val="F59E0B"/>
+            </a:solidFill>
+            <a:prstDash val="solid"/>
+          </a:ln>
+        </p:spPr>
+      </p:sp>
+      <p:sp>
+        <p:nvSpPr>
+          <p:cNvPr id="66" name="Text 63"/>
+          <p:cNvSpPr/>
+          <p:nvPr/>
+        </p:nvSpPr>
+        <p:spPr>
+          <a:xfrm>
+            <a:off x="7022592" y="3104388"/>
+            <a:ext cx="1792224" cy="182880"/>
+          </a:xfrm>
+          <a:prstGeom prst="rect">
+            <a:avLst/>
+          </a:prstGeom>
+          <a:noFill/>
+          <a:ln/>
+        </p:spPr>
+        <p:txBody>
+          <a:bodyPr wrap="square" lIns="12700" tIns="12700" rIns="12700" bIns="12700" rtlCol="0" anchor="ctr"/>
+          <a:lstStyle/>
+          <a:p>
+            <a:pPr algn="ctr" indent="0" marL="0">
+              <a:buNone/>
+            </a:pPr>
+            <a:r>
+              <a:rPr lang="en-US" sz="650" i="1" dirty="0">
+                <a:solidFill>
+                  <a:srgbClr val="92400E"/>
+                </a:solidFill>
+                <a:latin typeface="Calibri" pitchFamily="34" charset="0"/>
+                <a:ea typeface="Calibri" pitchFamily="34" charset="-122"/>
+                <a:cs typeface="Calibri" pitchFamily="34" charset="-120"/>
+              </a:rPr>
+              <a:t>ThreadPoolExecutor max_workers=2, Python concurrent.</a:t>
+            </a:r>
+            <a:endParaRPr lang="en-US" sz="650" dirty="0"/>
+          </a:p>
+        </p:txBody>
+      </p:sp>
+      <p:sp>
+        <p:nvSpPr>
+          <p:cNvPr id="67" name="Shape 64"/>
+          <p:cNvSpPr/>
+          <p:nvPr/>
+        </p:nvSpPr>
+        <p:spPr>
+          <a:xfrm>
+            <a:off x="2194560" y="1591056"/>
+            <a:ext cx="146304" cy="4572"/>
+          </a:xfrm>
+          <a:prstGeom prst="line">
+            <a:avLst/>
+          </a:prstGeom>
+          <a:noFill/>
+          <a:ln w="20320">
+            <a:solidFill>
+              <a:srgbClr val="94A3B8"/>
+            </a:solidFill>
+            <a:prstDash val="solid"/>
+          </a:ln>
+        </p:spPr>
+      </p:sp>
+      <p:sp>
+        <p:nvSpPr>
+          <p:cNvPr id="68" name="Shape 65"/>
+          <p:cNvSpPr/>
+          <p:nvPr/>
+        </p:nvSpPr>
+        <p:spPr>
+          <a:xfrm>
+            <a:off x="2340864" y="1591056"/>
+            <a:ext cx="4572" cy="1431036"/>
+          </a:xfrm>
+          <a:prstGeom prst="line">
+            <a:avLst/>
+          </a:prstGeom>
+          <a:noFill/>
+          <a:ln w="20320">
+            <a:solidFill>
+              <a:srgbClr val="94A3B8"/>
+            </a:solidFill>
+            <a:prstDash val="solid"/>
+          </a:ln>
+        </p:spPr>
+      </p:sp>
+      <p:sp>
+        <p:nvSpPr>
+          <p:cNvPr id="69" name="Shape 66"/>
+          <p:cNvSpPr/>
+          <p:nvPr/>
+        </p:nvSpPr>
+        <p:spPr>
+          <a:xfrm>
+            <a:off x="2340864" y="3022092"/>
+            <a:ext cx="146304" cy="4572"/>
+          </a:xfrm>
+          <a:prstGeom prst="line">
+            <a:avLst/>
+          </a:prstGeom>
+          <a:noFill/>
+          <a:ln w="20320">
+            <a:solidFill>
+              <a:srgbClr val="475569"/>
+            </a:solidFill>
+            <a:prstDash val="solid"/>
+            <a:tailEnd type="triangle"/>
+          </a:ln>
+        </p:spPr>
+      </p:sp>
+      <p:sp>
+        <p:nvSpPr>
+          <p:cNvPr id="70" name="Shape 67"/>
+          <p:cNvSpPr/>
+          <p:nvPr/>
+        </p:nvSpPr>
+        <p:spPr>
+          <a:xfrm>
+            <a:off x="1828800" y="2205990"/>
+            <a:ext cx="1024128" cy="201168"/>
+          </a:xfrm>
+          <a:prstGeom prst="roundRect">
+            <a:avLst>
+              <a:gd name="adj" fmla="val 22727"/>
+            </a:avLst>
+          </a:prstGeom>
+          <a:solidFill>
+            <a:srgbClr val="F8FAFC"/>
+          </a:solidFill>
+          <a:ln w="10160">
+            <a:solidFill>
+              <a:srgbClr val="CBD5E1"/>
+            </a:solidFill>
+            <a:prstDash val="solid"/>
+          </a:ln>
+        </p:spPr>
+      </p:sp>
+      <p:sp>
+        <p:nvSpPr>
+          <p:cNvPr id="71" name="Text 68"/>
+          <p:cNvSpPr/>
+          <p:nvPr/>
+        </p:nvSpPr>
+        <p:spPr>
+          <a:xfrm>
+            <a:off x="1828800" y="2205990"/>
+            <a:ext cx="1024128" cy="201168"/>
+          </a:xfrm>
+          <a:prstGeom prst="rect">
+            <a:avLst/>
+          </a:prstGeom>
+          <a:noFill/>
+          <a:ln/>
+        </p:spPr>
+        <p:txBody>
+          <a:bodyPr wrap="square" lIns="25400" tIns="25400" rIns="25400" bIns="25400" rtlCol="0" anchor="ctr"/>
+          <a:lstStyle/>
+          <a:p>
+            <a:pPr algn="ctr" indent="0" marL="0">
+              <a:buNone/>
+            </a:pPr>
+            <a:r>
+              <a:rPr lang="en-US" sz="650" dirty="0">
+                <a:solidFill>
+                  <a:srgbClr val="334155"/>
+                </a:solidFill>
+                <a:latin typeface="Calibri" pitchFamily="34" charset="0"/>
+                <a:ea typeface="Calibri" pitchFamily="34" charset="-122"/>
+                <a:cs typeface="Calibri" pitchFamily="34" charset="-120"/>
+              </a:rPr>
+              <a:t>Browser Interaction</a:t>
+            </a:r>
+            <a:endParaRPr lang="en-US" sz="650" dirty="0"/>
+          </a:p>
+        </p:txBody>
+      </p:sp>
+      <p:sp>
+        <p:nvSpPr>
+          <p:cNvPr id="72" name="Shape 69"/>
+          <p:cNvSpPr/>
+          <p:nvPr/>
+        </p:nvSpPr>
+        <p:spPr>
+          <a:xfrm>
+            <a:off x="4425696" y="3022092"/>
+            <a:ext cx="146304" cy="4572"/>
+          </a:xfrm>
+          <a:prstGeom prst="line">
+            <a:avLst/>
+          </a:prstGeom>
+          <a:noFill/>
+          <a:ln w="20320">
+            <a:solidFill>
+              <a:srgbClr val="94A3B8"/>
+            </a:solidFill>
+            <a:prstDash val="solid"/>
+          </a:ln>
+        </p:spPr>
+      </p:sp>
+      <p:sp>
+        <p:nvSpPr>
+          <p:cNvPr id="73" name="Shape 70"/>
+          <p:cNvSpPr/>
+          <p:nvPr/>
+        </p:nvSpPr>
+        <p:spPr>
+          <a:xfrm>
+            <a:off x="4572000" y="1591056"/>
+            <a:ext cx="4572" cy="1431036"/>
+          </a:xfrm>
+          <a:prstGeom prst="line">
+            <a:avLst/>
+          </a:prstGeom>
+          <a:noFill/>
+          <a:ln w="20320">
+            <a:solidFill>
+              <a:srgbClr val="94A3B8"/>
+            </a:solidFill>
+            <a:prstDash val="solid"/>
+          </a:ln>
+        </p:spPr>
+      </p:sp>
+      <p:sp>
+        <p:nvSpPr>
+          <p:cNvPr id="74" name="Shape 71"/>
+          <p:cNvSpPr/>
+          <p:nvPr/>
+        </p:nvSpPr>
+        <p:spPr>
+          <a:xfrm>
+            <a:off x="4572000" y="1591056"/>
+            <a:ext cx="146304" cy="4572"/>
+          </a:xfrm>
+          <a:prstGeom prst="line">
+            <a:avLst/>
+          </a:prstGeom>
+          <a:noFill/>
+          <a:ln w="20320">
+            <a:solidFill>
+              <a:srgbClr val="475569"/>
+            </a:solidFill>
+            <a:prstDash val="solid"/>
+            <a:tailEnd type="triangle"/>
+          </a:ln>
+        </p:spPr>
+      </p:sp>
+      <p:sp>
+        <p:nvSpPr>
+          <p:cNvPr id="75" name="Shape 72"/>
+          <p:cNvSpPr/>
+          <p:nvPr/>
+        </p:nvSpPr>
+        <p:spPr>
+          <a:xfrm>
+            <a:off x="4059936" y="2205990"/>
+            <a:ext cx="1024128" cy="201168"/>
+          </a:xfrm>
+          <a:prstGeom prst="roundRect">
+            <a:avLst>
+              <a:gd name="adj" fmla="val 22727"/>
+            </a:avLst>
+          </a:prstGeom>
+          <a:solidFill>
+            <a:srgbClr val="F8FAFC"/>
+          </a:solidFill>
+          <a:ln w="10160">
+            <a:solidFill>
+              <a:srgbClr val="CBD5E1"/>
+            </a:solidFill>
+            <a:prstDash val="solid"/>
+          </a:ln>
+        </p:spPr>
+      </p:sp>
+      <p:sp>
+        <p:nvSpPr>
+          <p:cNvPr id="76" name="Text 73"/>
+          <p:cNvSpPr/>
+          <p:nvPr/>
+        </p:nvSpPr>
+        <p:spPr>
+          <a:xfrm>
+            <a:off x="4059936" y="2205990"/>
+            <a:ext cx="1024128" cy="201168"/>
+          </a:xfrm>
+          <a:prstGeom prst="rect">
+            <a:avLst/>
+          </a:prstGeom>
+          <a:noFill/>
+          <a:ln/>
+        </p:spPr>
+        <p:txBody>
+          <a:bodyPr wrap="square" lIns="25400" tIns="25400" rIns="25400" bIns="25400" rtlCol="0" anchor="ctr"/>
+          <a:lstStyle/>
+          <a:p>
+            <a:pPr algn="ctr" indent="0" marL="0">
+              <a:buNone/>
+            </a:pPr>
+            <a:r>
+              <a:rPr lang="en-US" sz="650" dirty="0">
+                <a:solidFill>
+                  <a:srgbClr val="334155"/>
+                </a:solidFill>
+                <a:latin typeface="Calibri" pitchFamily="34" charset="0"/>
+                <a:ea typeface="Calibri" pitchFamily="34" charset="-122"/>
+                <a:cs typeface="Calibri" pitchFamily="34" charset="-120"/>
+              </a:rPr>
+              <a:t>Multipart File Upload (HTTP …</a:t>
+            </a:r>
+            <a:endParaRPr lang="en-US" sz="650" dirty="0"/>
+          </a:p>
+        </p:txBody>
+      </p:sp>
+      <p:sp>
+        <p:nvSpPr>
+          <p:cNvPr id="77" name="Shape 74"/>
+          <p:cNvSpPr/>
+          <p:nvPr/>
+        </p:nvSpPr>
+        <p:spPr>
+          <a:xfrm>
+            <a:off x="5687568" y="1901952"/>
+            <a:ext cx="4572" cy="332232"/>
+          </a:xfrm>
+          <a:prstGeom prst="line">
+            <a:avLst/>
+          </a:prstGeom>
+          <a:noFill/>
+          <a:ln w="20320">
+            <a:solidFill>
+              <a:srgbClr val="475569"/>
+            </a:solidFill>
+            <a:prstDash val="solid"/>
+            <a:tailEnd type="triangle"/>
+          </a:ln>
+        </p:spPr>
+      </p:sp>
+      <p:sp>
+        <p:nvSpPr>
+          <p:cNvPr id="78" name="Shape 75"/>
+          <p:cNvSpPr/>
+          <p:nvPr/>
+        </p:nvSpPr>
+        <p:spPr>
+          <a:xfrm>
+            <a:off x="5175504" y="1967484"/>
+            <a:ext cx="1024128" cy="201168"/>
+          </a:xfrm>
+          <a:prstGeom prst="roundRect">
+            <a:avLst>
+              <a:gd name="adj" fmla="val 22727"/>
+            </a:avLst>
+          </a:prstGeom>
+          <a:solidFill>
+            <a:srgbClr val="F8FAFC"/>
+          </a:solidFill>
+          <a:ln w="10160">
+            <a:solidFill>
+              <a:srgbClr val="CBD5E1"/>
+            </a:solidFill>
+            <a:prstDash val="solid"/>
+          </a:ln>
+        </p:spPr>
+      </p:sp>
+      <p:sp>
+        <p:nvSpPr>
+          <p:cNvPr id="79" name="Text 76"/>
+          <p:cNvSpPr/>
+          <p:nvPr/>
+        </p:nvSpPr>
+        <p:spPr>
+          <a:xfrm>
+            <a:off x="5175504" y="1967484"/>
+            <a:ext cx="1024128" cy="201168"/>
+          </a:xfrm>
+          <a:prstGeom prst="rect">
+            <a:avLst/>
+          </a:prstGeom>
+          <a:noFill/>
+          <a:ln/>
+        </p:spPr>
+        <p:txBody>
+          <a:bodyPr wrap="square" lIns="25400" tIns="25400" rIns="25400" bIns="25400" rtlCol="0" anchor="ctr"/>
+          <a:lstStyle/>
+          <a:p>
+            <a:pPr algn="ctr" indent="0" marL="0">
+              <a:buNone/>
+            </a:pPr>
+            <a:r>
+              <a:rPr lang="en-US" sz="650" dirty="0">
+                <a:solidFill>
+                  <a:srgbClr val="334155"/>
+                </a:solidFill>
+                <a:latin typeface="Calibri" pitchFamily="34" charset="0"/>
+                <a:ea typeface="Calibri" pitchFamily="34" charset="-122"/>
+                <a:cs typeface="Calibri" pitchFamily="34" charset="-120"/>
+              </a:rPr>
+              <a:t>Raw Attribute Strings</a:t>
+            </a:r>
+            <a:endParaRPr lang="en-US" sz="650" dirty="0"/>
+          </a:p>
+        </p:txBody>
+      </p:sp>
+      <p:sp>
+        <p:nvSpPr>
+          <p:cNvPr id="80" name="Shape 77"/>
+          <p:cNvSpPr/>
+          <p:nvPr/>
+        </p:nvSpPr>
+        <p:spPr>
+          <a:xfrm>
+            <a:off x="5687568" y="2855976"/>
+            <a:ext cx="4572" cy="332232"/>
+          </a:xfrm>
+          <a:prstGeom prst="line">
+            <a:avLst/>
+          </a:prstGeom>
+          <a:noFill/>
+          <a:ln w="20320">
+            <a:solidFill>
+              <a:srgbClr val="475569"/>
+            </a:solidFill>
+            <a:prstDash val="solid"/>
+            <a:tailEnd type="triangle"/>
+          </a:ln>
+        </p:spPr>
+      </p:sp>
+      <p:sp>
+        <p:nvSpPr>
+          <p:cNvPr id="81" name="Shape 78"/>
+          <p:cNvSpPr/>
+          <p:nvPr/>
+        </p:nvSpPr>
+        <p:spPr>
+          <a:xfrm>
+            <a:off x="5175504" y="2921508"/>
+            <a:ext cx="1024128" cy="201168"/>
+          </a:xfrm>
+          <a:prstGeom prst="roundRect">
+            <a:avLst>
+              <a:gd name="adj" fmla="val 22727"/>
+            </a:avLst>
+          </a:prstGeom>
+          <a:solidFill>
+            <a:srgbClr val="F8FAFC"/>
+          </a:solidFill>
+          <a:ln w="10160">
+            <a:solidFill>
+              <a:srgbClr val="CBD5E1"/>
+            </a:solidFill>
+            <a:prstDash val="solid"/>
+          </a:ln>
+        </p:spPr>
+      </p:sp>
+      <p:sp>
+        <p:nvSpPr>
+          <p:cNvPr id="82" name="Text 79"/>
+          <p:cNvSpPr/>
+          <p:nvPr/>
+        </p:nvSpPr>
+        <p:spPr>
+          <a:xfrm>
+            <a:off x="5175504" y="2921508"/>
+            <a:ext cx="1024128" cy="201168"/>
+          </a:xfrm>
+          <a:prstGeom prst="rect">
+            <a:avLst/>
+          </a:prstGeom>
+          <a:noFill/>
+          <a:ln/>
+        </p:spPr>
+        <p:txBody>
+          <a:bodyPr wrap="square" lIns="25400" tIns="25400" rIns="25400" bIns="25400" rtlCol="0" anchor="ctr"/>
+          <a:lstStyle/>
+          <a:p>
+            <a:pPr algn="ctr" indent="0" marL="0">
+              <a:buNone/>
+            </a:pPr>
+            <a:r>
+              <a:rPr lang="en-US" sz="650" dirty="0">
+                <a:solidFill>
+                  <a:srgbClr val="334155"/>
+                </a:solidFill>
+                <a:latin typeface="Calibri" pitchFamily="34" charset="0"/>
+                <a:ea typeface="Calibri" pitchFamily="34" charset="-122"/>
+                <a:cs typeface="Calibri" pitchFamily="34" charset="-120"/>
+              </a:rPr>
+              <a:t>Normalised Attribute Pairs</a:t>
+            </a:r>
+            <a:endParaRPr lang="en-US" sz="650" dirty="0"/>
+          </a:p>
+        </p:txBody>
+      </p:sp>
+      <p:sp>
+        <p:nvSpPr>
+          <p:cNvPr id="83" name="Shape 80"/>
+          <p:cNvSpPr/>
+          <p:nvPr/>
+        </p:nvSpPr>
+        <p:spPr>
+          <a:xfrm>
+            <a:off x="6656832" y="3499104"/>
+            <a:ext cx="146304" cy="4572"/>
+          </a:xfrm>
+          <a:prstGeom prst="line">
+            <a:avLst/>
+          </a:prstGeom>
+          <a:noFill/>
+          <a:ln w="20320">
+            <a:solidFill>
+              <a:srgbClr val="94A3B8"/>
+            </a:solidFill>
+            <a:prstDash val="solid"/>
+          </a:ln>
+        </p:spPr>
+      </p:sp>
+      <p:sp>
+        <p:nvSpPr>
+          <p:cNvPr id="84" name="Shape 81"/>
+          <p:cNvSpPr/>
+          <p:nvPr/>
+        </p:nvSpPr>
+        <p:spPr>
+          <a:xfrm>
+            <a:off x="6803136" y="3022092"/>
+            <a:ext cx="4572" cy="477012"/>
+          </a:xfrm>
+          <a:prstGeom prst="line">
+            <a:avLst/>
+          </a:prstGeom>
+          <a:noFill/>
+          <a:ln w="20320">
+            <a:solidFill>
+              <a:srgbClr val="94A3B8"/>
+            </a:solidFill>
+            <a:prstDash val="solid"/>
+          </a:ln>
+        </p:spPr>
+      </p:sp>
+      <p:sp>
+        <p:nvSpPr>
+          <p:cNvPr id="85" name="Shape 82"/>
+          <p:cNvSpPr/>
+          <p:nvPr/>
+        </p:nvSpPr>
+        <p:spPr>
+          <a:xfrm>
+            <a:off x="6803136" y="3022092"/>
+            <a:ext cx="146304" cy="4572"/>
+          </a:xfrm>
+          <a:prstGeom prst="line">
+            <a:avLst/>
+          </a:prstGeom>
+          <a:noFill/>
+          <a:ln w="20320">
+            <a:solidFill>
+              <a:srgbClr val="475569"/>
+            </a:solidFill>
+            <a:prstDash val="solid"/>
+            <a:tailEnd type="triangle"/>
+          </a:ln>
+        </p:spPr>
+      </p:sp>
+      <p:sp>
+        <p:nvSpPr>
+          <p:cNvPr id="86" name="Shape 83"/>
+          <p:cNvSpPr/>
+          <p:nvPr/>
+        </p:nvSpPr>
+        <p:spPr>
+          <a:xfrm>
+            <a:off x="6291072" y="3160014"/>
+            <a:ext cx="1024128" cy="201168"/>
+          </a:xfrm>
+          <a:prstGeom prst="roundRect">
+            <a:avLst>
+              <a:gd name="adj" fmla="val 22727"/>
+            </a:avLst>
+          </a:prstGeom>
+          <a:solidFill>
+            <a:srgbClr val="F8FAFC"/>
+          </a:solidFill>
+          <a:ln w="10160">
+            <a:solidFill>
+              <a:srgbClr val="CBD5E1"/>
+            </a:solidFill>
+            <a:prstDash val="solid"/>
+          </a:ln>
+        </p:spPr>
+      </p:sp>
+      <p:sp>
+        <p:nvSpPr>
+          <p:cNvPr id="87" name="Text 84"/>
+          <p:cNvSpPr/>
+          <p:nvPr/>
+        </p:nvSpPr>
+        <p:spPr>
+          <a:xfrm>
+            <a:off x="6291072" y="3160014"/>
+            <a:ext cx="1024128" cy="201168"/>
+          </a:xfrm>
+          <a:prstGeom prst="rect">
+            <a:avLst/>
+          </a:prstGeom>
+          <a:noFill/>
+          <a:ln/>
+        </p:spPr>
+        <p:txBody>
+          <a:bodyPr wrap="square" lIns="25400" tIns="25400" rIns="25400" bIns="25400" rtlCol="0" anchor="ctr"/>
+          <a:lstStyle/>
+          <a:p>
+            <a:pPr algn="ctr" indent="0" marL="0">
+              <a:buNone/>
+            </a:pPr>
+            <a:r>
+              <a:rPr lang="en-US" sz="650" dirty="0">
+                <a:solidFill>
+                  <a:srgbClr val="334155"/>
+                </a:solidFill>
+                <a:latin typeface="Calibri" pitchFamily="34" charset="0"/>
+                <a:ea typeface="Calibri" pitchFamily="34" charset="-122"/>
+                <a:cs typeface="Calibri" pitchFamily="34" charset="-120"/>
+              </a:rPr>
+              <a:t>Candidate Pairs Above Thresh…</a:t>
+            </a:r>
+            <a:endParaRPr lang="en-US" sz="650" dirty="0"/>
+          </a:p>
+        </p:txBody>
+      </p:sp>
+      <p:sp>
+        <p:nvSpPr>
+          <p:cNvPr id="88" name="Shape 85"/>
+          <p:cNvSpPr/>
+          <p:nvPr/>
+        </p:nvSpPr>
+        <p:spPr>
+          <a:xfrm>
+            <a:off x="4572000" y="3022092"/>
+            <a:ext cx="2377440" cy="4572"/>
+          </a:xfrm>
+          <a:prstGeom prst="line">
+            <a:avLst/>
+          </a:prstGeom>
+          <a:noFill/>
+          <a:ln w="20320">
+            <a:solidFill>
+              <a:srgbClr val="94A3B8"/>
+            </a:solidFill>
+            <a:prstDash val="solid"/>
+          </a:ln>
+        </p:spPr>
+      </p:sp>
+      <p:sp>
+        <p:nvSpPr>
+          <p:cNvPr id="89" name="Shape 86"/>
+          <p:cNvSpPr/>
+          <p:nvPr/>
+        </p:nvSpPr>
+        <p:spPr>
+          <a:xfrm>
+            <a:off x="4572000" y="3022092"/>
+            <a:ext cx="4572" cy="1431036"/>
+          </a:xfrm>
+          <a:prstGeom prst="line">
+            <a:avLst/>
+          </a:prstGeom>
+          <a:noFill/>
+          <a:ln w="20320">
+            <a:solidFill>
+              <a:srgbClr val="94A3B8"/>
+            </a:solidFill>
+            <a:prstDash val="solid"/>
+          </a:ln>
+        </p:spPr>
+      </p:sp>
+      <p:sp>
+        <p:nvSpPr>
+          <p:cNvPr id="90" name="Shape 87"/>
+          <p:cNvSpPr/>
+          <p:nvPr/>
+        </p:nvSpPr>
+        <p:spPr>
+          <a:xfrm>
+            <a:off x="2194560" y="4453128"/>
+            <a:ext cx="2377440" cy="4572"/>
+          </a:xfrm>
+          <a:prstGeom prst="line">
+            <a:avLst/>
+          </a:prstGeom>
+          <a:noFill/>
+          <a:ln w="20320">
+            <a:solidFill>
+              <a:srgbClr val="475569"/>
+            </a:solidFill>
+            <a:prstDash val="solid"/>
+            <a:tailEnd type="triangle"/>
+          </a:ln>
+        </p:spPr>
+      </p:sp>
+      <p:sp>
+        <p:nvSpPr>
+          <p:cNvPr id="91" name="Shape 88"/>
+          <p:cNvSpPr/>
+          <p:nvPr/>
+        </p:nvSpPr>
+        <p:spPr>
+          <a:xfrm>
+            <a:off x="4059936" y="3637026"/>
+            <a:ext cx="1024128" cy="201168"/>
+          </a:xfrm>
+          <a:prstGeom prst="roundRect">
+            <a:avLst>
+              <a:gd name="adj" fmla="val 22727"/>
+            </a:avLst>
+          </a:prstGeom>
+          <a:solidFill>
+            <a:srgbClr val="F8FAFC"/>
+          </a:solidFill>
+          <a:ln w="10160">
+            <a:solidFill>
+              <a:srgbClr val="CBD5E1"/>
+            </a:solidFill>
+            <a:prstDash val="solid"/>
+          </a:ln>
+        </p:spPr>
+      </p:sp>
+      <p:sp>
+        <p:nvSpPr>
+          <p:cNvPr id="92" name="Text 89"/>
+          <p:cNvSpPr/>
+          <p:nvPr/>
+        </p:nvSpPr>
+        <p:spPr>
+          <a:xfrm>
+            <a:off x="4059936" y="3637026"/>
+            <a:ext cx="1024128" cy="201168"/>
+          </a:xfrm>
+          <a:prstGeom prst="rect">
+            <a:avLst/>
+          </a:prstGeom>
+          <a:noFill/>
+          <a:ln/>
+        </p:spPr>
+        <p:txBody>
+          <a:bodyPr wrap="square" lIns="25400" tIns="25400" rIns="25400" bIns="25400" rtlCol="0" anchor="ctr"/>
+          <a:lstStyle/>
+          <a:p>
+            <a:pPr algn="ctr" indent="0" marL="0">
+              <a:buNone/>
+            </a:pPr>
+            <a:r>
+              <a:rPr lang="en-US" sz="650" dirty="0">
+                <a:solidFill>
+                  <a:srgbClr val="334155"/>
+                </a:solidFill>
+                <a:latin typeface="Calibri" pitchFamily="34" charset="0"/>
+                <a:ea typeface="Calibri" pitchFamily="34" charset="-122"/>
+                <a:cs typeface="Calibri" pitchFamily="34" charset="-120"/>
+              </a:rPr>
+              <a:t>Batched JSON Prompt (25 pairs)</a:t>
+            </a:r>
+            <a:endParaRPr lang="en-US" sz="650" dirty="0"/>
+          </a:p>
+        </p:txBody>
+      </p:sp>
+      <p:sp>
+        <p:nvSpPr>
+          <p:cNvPr id="93" name="Shape 90"/>
+          <p:cNvSpPr/>
+          <p:nvPr/>
+        </p:nvSpPr>
+        <p:spPr>
+          <a:xfrm>
+            <a:off x="2194560" y="4453128"/>
+            <a:ext cx="2377440" cy="4572"/>
+          </a:xfrm>
+          <a:prstGeom prst="line">
+            <a:avLst/>
+          </a:prstGeom>
+          <a:noFill/>
+          <a:ln w="20320">
+            <a:solidFill>
+              <a:srgbClr val="94A3B8"/>
+            </a:solidFill>
+            <a:prstDash val="solid"/>
+          </a:ln>
+        </p:spPr>
+      </p:sp>
+      <p:sp>
+        <p:nvSpPr>
+          <p:cNvPr id="94" name="Shape 91"/>
+          <p:cNvSpPr/>
+          <p:nvPr/>
+        </p:nvSpPr>
+        <p:spPr>
+          <a:xfrm>
+            <a:off x="4572000" y="3022092"/>
+            <a:ext cx="4572" cy="1431036"/>
+          </a:xfrm>
+          <a:prstGeom prst="line">
+            <a:avLst/>
+          </a:prstGeom>
+          <a:noFill/>
+          <a:ln w="20320">
+            <a:solidFill>
+              <a:srgbClr val="94A3B8"/>
+            </a:solidFill>
+            <a:prstDash val="solid"/>
+          </a:ln>
+        </p:spPr>
+      </p:sp>
+      <p:sp>
+        <p:nvSpPr>
+          <p:cNvPr id="95" name="Shape 92"/>
+          <p:cNvSpPr/>
+          <p:nvPr/>
+        </p:nvSpPr>
+        <p:spPr>
+          <a:xfrm>
+            <a:off x="4572000" y="3022092"/>
+            <a:ext cx="2377440" cy="4572"/>
+          </a:xfrm>
+          <a:prstGeom prst="line">
+            <a:avLst/>
+          </a:prstGeom>
+          <a:noFill/>
+          <a:ln w="20320">
+            <a:solidFill>
+              <a:srgbClr val="475569"/>
+            </a:solidFill>
+            <a:prstDash val="solid"/>
+            <a:tailEnd type="triangle"/>
+          </a:ln>
+        </p:spPr>
+      </p:sp>
+      <p:sp>
+        <p:nvSpPr>
+          <p:cNvPr id="96" name="Shape 93"/>
+          <p:cNvSpPr/>
+          <p:nvPr/>
+        </p:nvSpPr>
+        <p:spPr>
+          <a:xfrm>
+            <a:off x="4059936" y="3637026"/>
+            <a:ext cx="1024128" cy="201168"/>
+          </a:xfrm>
+          <a:prstGeom prst="roundRect">
+            <a:avLst>
+              <a:gd name="adj" fmla="val 22727"/>
+            </a:avLst>
+          </a:prstGeom>
+          <a:solidFill>
+            <a:srgbClr val="F8FAFC"/>
+          </a:solidFill>
+          <a:ln w="10160">
+            <a:solidFill>
+              <a:srgbClr val="CBD5E1"/>
+            </a:solidFill>
+            <a:prstDash val="solid"/>
+          </a:ln>
+        </p:spPr>
+      </p:sp>
+      <p:sp>
+        <p:nvSpPr>
+          <p:cNvPr id="97" name="Text 94"/>
+          <p:cNvSpPr/>
+          <p:nvPr/>
+        </p:nvSpPr>
+        <p:spPr>
+          <a:xfrm>
+            <a:off x="4059936" y="3637026"/>
+            <a:ext cx="1024128" cy="201168"/>
+          </a:xfrm>
+          <a:prstGeom prst="rect">
+            <a:avLst/>
+          </a:prstGeom>
+          <a:noFill/>
+          <a:ln/>
+        </p:spPr>
+        <p:txBody>
+          <a:bodyPr wrap="square" lIns="25400" tIns="25400" rIns="25400" bIns="25400" rtlCol="0" anchor="ctr"/>
+          <a:lstStyle/>
+          <a:p>
+            <a:pPr algn="ctr" indent="0" marL="0">
+              <a:buNone/>
+            </a:pPr>
+            <a:r>
+              <a:rPr lang="en-US" sz="650" dirty="0">
+                <a:solidFill>
+                  <a:srgbClr val="334155"/>
+                </a:solidFill>
+                <a:latin typeface="Calibri" pitchFamily="34" charset="0"/>
+                <a:ea typeface="Calibri" pitchFamily="34" charset="-122"/>
+                <a:cs typeface="Calibri" pitchFamily="34" charset="-120"/>
+              </a:rPr>
+              <a:t>JSON Semantic Scores Response</a:t>
+            </a:r>
+            <a:endParaRPr lang="en-US" sz="650" dirty="0"/>
+          </a:p>
+        </p:txBody>
+      </p:sp>
+      <p:sp>
+        <p:nvSpPr>
+          <p:cNvPr id="98" name="Shape 95"/>
+          <p:cNvSpPr/>
+          <p:nvPr/>
+        </p:nvSpPr>
+        <p:spPr>
+          <a:xfrm>
+            <a:off x="6803136" y="3022092"/>
+            <a:ext cx="146304" cy="4572"/>
+          </a:xfrm>
+          <a:prstGeom prst="line">
+            <a:avLst/>
+          </a:prstGeom>
+          <a:noFill/>
+          <a:ln w="20320">
+            <a:solidFill>
+              <a:srgbClr val="94A3B8"/>
+            </a:solidFill>
+            <a:prstDash val="solid"/>
+          </a:ln>
+        </p:spPr>
+      </p:sp>
+      <p:sp>
+        <p:nvSpPr>
+          <p:cNvPr id="99" name="Shape 96"/>
+          <p:cNvSpPr/>
+          <p:nvPr/>
+        </p:nvSpPr>
+        <p:spPr>
+          <a:xfrm>
+            <a:off x="6803136" y="3022092"/>
+            <a:ext cx="4572" cy="1431036"/>
+          </a:xfrm>
+          <a:prstGeom prst="line">
+            <a:avLst/>
+          </a:prstGeom>
+          <a:noFill/>
+          <a:ln w="20320">
+            <a:solidFill>
+              <a:srgbClr val="94A3B8"/>
+            </a:solidFill>
+            <a:prstDash val="solid"/>
+          </a:ln>
+        </p:spPr>
+      </p:sp>
+      <p:sp>
+        <p:nvSpPr>
+          <p:cNvPr id="100" name="Shape 97"/>
+          <p:cNvSpPr/>
+          <p:nvPr/>
+        </p:nvSpPr>
+        <p:spPr>
+          <a:xfrm>
+            <a:off x="6656832" y="4453128"/>
+            <a:ext cx="146304" cy="4572"/>
+          </a:xfrm>
+          <a:prstGeom prst="line">
+            <a:avLst/>
+          </a:prstGeom>
+          <a:noFill/>
+          <a:ln w="20320">
+            <a:solidFill>
+              <a:srgbClr val="475569"/>
+            </a:solidFill>
+            <a:prstDash val="solid"/>
+            <a:tailEnd type="triangle"/>
+          </a:ln>
+        </p:spPr>
+      </p:sp>
+      <p:sp>
+        <p:nvSpPr>
+          <p:cNvPr id="101" name="Shape 98"/>
+          <p:cNvSpPr/>
+          <p:nvPr/>
+        </p:nvSpPr>
+        <p:spPr>
+          <a:xfrm>
+            <a:off x="6291072" y="3637026"/>
+            <a:ext cx="1024128" cy="201168"/>
+          </a:xfrm>
+          <a:prstGeom prst="roundRect">
+            <a:avLst>
+              <a:gd name="adj" fmla="val 22727"/>
+            </a:avLst>
+          </a:prstGeom>
+          <a:solidFill>
+            <a:srgbClr val="F8FAFC"/>
+          </a:solidFill>
+          <a:ln w="10160">
+            <a:solidFill>
+              <a:srgbClr val="CBD5E1"/>
+            </a:solidFill>
+            <a:prstDash val="solid"/>
+          </a:ln>
+        </p:spPr>
+      </p:sp>
+      <p:sp>
+        <p:nvSpPr>
+          <p:cNvPr id="102" name="Text 99"/>
+          <p:cNvSpPr/>
+          <p:nvPr/>
+        </p:nvSpPr>
+        <p:spPr>
+          <a:xfrm>
+            <a:off x="6291072" y="3637026"/>
+            <a:ext cx="1024128" cy="201168"/>
+          </a:xfrm>
+          <a:prstGeom prst="rect">
+            <a:avLst/>
+          </a:prstGeom>
+          <a:noFill/>
+          <a:ln/>
+        </p:spPr>
+        <p:txBody>
+          <a:bodyPr wrap="square" lIns="25400" tIns="25400" rIns="25400" bIns="25400" rtlCol="0" anchor="ctr"/>
+          <a:lstStyle/>
+          <a:p>
+            <a:pPr algn="ctr" indent="0" marL="0">
+              <a:buNone/>
+            </a:pPr>
+            <a:r>
+              <a:rPr lang="en-US" sz="650" dirty="0">
+                <a:solidFill>
+                  <a:srgbClr val="334155"/>
+                </a:solidFill>
+                <a:latin typeface="Calibri" pitchFamily="34" charset="0"/>
+                <a:ea typeface="Calibri" pitchFamily="34" charset="-122"/>
+                <a:cs typeface="Calibri" pitchFamily="34" charset="-120"/>
+              </a:rPr>
+              <a:t>Merged Hybrid Scores</a:t>
+            </a:r>
+            <a:endParaRPr lang="en-US" sz="650" dirty="0"/>
+          </a:p>
+        </p:txBody>
+      </p:sp>
+      <p:sp>
+        <p:nvSpPr>
+          <p:cNvPr id="103" name="Shape 100"/>
+          <p:cNvSpPr/>
+          <p:nvPr/>
+        </p:nvSpPr>
+        <p:spPr>
+          <a:xfrm>
+            <a:off x="4572000" y="4453128"/>
+            <a:ext cx="146304" cy="4572"/>
+          </a:xfrm>
+          <a:prstGeom prst="line">
+            <a:avLst/>
+          </a:prstGeom>
+          <a:noFill/>
+          <a:ln w="20320">
+            <a:solidFill>
+              <a:srgbClr val="94A3B8"/>
+            </a:solidFill>
+            <a:prstDash val="solid"/>
+          </a:ln>
+        </p:spPr>
+      </p:sp>
+      <p:sp>
+        <p:nvSpPr>
+          <p:cNvPr id="104" name="Shape 101"/>
+          <p:cNvSpPr/>
+          <p:nvPr/>
+        </p:nvSpPr>
+        <p:spPr>
+          <a:xfrm>
+            <a:off x="4572000" y="3022092"/>
+            <a:ext cx="4572" cy="1431036"/>
+          </a:xfrm>
+          <a:prstGeom prst="line">
+            <a:avLst/>
+          </a:prstGeom>
+          <a:noFill/>
+          <a:ln w="20320">
+            <a:solidFill>
+              <a:srgbClr val="94A3B8"/>
+            </a:solidFill>
+            <a:prstDash val="solid"/>
+          </a:ln>
+        </p:spPr>
+      </p:sp>
+      <p:sp>
+        <p:nvSpPr>
+          <p:cNvPr id="105" name="Shape 102"/>
+          <p:cNvSpPr/>
+          <p:nvPr/>
+        </p:nvSpPr>
+        <p:spPr>
+          <a:xfrm>
+            <a:off x="4425696" y="3022092"/>
+            <a:ext cx="146304" cy="4572"/>
+          </a:xfrm>
+          <a:prstGeom prst="line">
+            <a:avLst/>
+          </a:prstGeom>
+          <a:noFill/>
+          <a:ln w="20320">
+            <a:solidFill>
+              <a:srgbClr val="475569"/>
+            </a:solidFill>
+            <a:prstDash val="solid"/>
+            <a:tailEnd type="triangle"/>
+          </a:ln>
+        </p:spPr>
+      </p:sp>
+      <p:sp>
+        <p:nvSpPr>
+          <p:cNvPr id="106" name="Shape 103"/>
+          <p:cNvSpPr/>
+          <p:nvPr/>
+        </p:nvSpPr>
+        <p:spPr>
+          <a:xfrm>
+            <a:off x="4059936" y="3637026"/>
+            <a:ext cx="1024128" cy="201168"/>
+          </a:xfrm>
+          <a:prstGeom prst="roundRect">
+            <a:avLst>
+              <a:gd name="adj" fmla="val 22727"/>
+            </a:avLst>
+          </a:prstGeom>
+          <a:solidFill>
+            <a:srgbClr val="F8FAFC"/>
+          </a:solidFill>
+          <a:ln w="10160">
+            <a:solidFill>
+              <a:srgbClr val="CBD5E1"/>
+            </a:solidFill>
+            <a:prstDash val="solid"/>
+          </a:ln>
+        </p:spPr>
+      </p:sp>
+      <p:sp>
+        <p:nvSpPr>
+          <p:cNvPr id="107" name="Text 104"/>
+          <p:cNvSpPr/>
+          <p:nvPr/>
+        </p:nvSpPr>
+        <p:spPr>
+          <a:xfrm>
+            <a:off x="4059936" y="3637026"/>
+            <a:ext cx="1024128" cy="201168"/>
+          </a:xfrm>
+          <a:prstGeom prst="rect">
+            <a:avLst/>
+          </a:prstGeom>
+          <a:noFill/>
+          <a:ln/>
+        </p:spPr>
+        <p:txBody>
+          <a:bodyPr wrap="square" lIns="25400" tIns="25400" rIns="25400" bIns="25400" rtlCol="0" anchor="ctr"/>
+          <a:lstStyle/>
+          <a:p>
+            <a:pPr algn="ctr" indent="0" marL="0">
+              <a:buNone/>
+            </a:pPr>
+            <a:r>
+              <a:rPr lang="en-US" sz="650" dirty="0">
+                <a:solidFill>
+                  <a:srgbClr val="334155"/>
+                </a:solidFill>
+                <a:latin typeface="Calibri" pitchFamily="34" charset="0"/>
+                <a:ea typeface="Calibri" pitchFamily="34" charset="-122"/>
+                <a:cs typeface="Calibri" pitchFamily="34" charset="-120"/>
+              </a:rPr>
+              <a:t>Excel File Download Response</a:t>
+            </a:r>
+            <a:endParaRPr lang="en-US" sz="650" dirty="0"/>
+          </a:p>
+        </p:txBody>
+      </p:sp>
+      <p:sp>
+        <p:nvSpPr>
+          <p:cNvPr id="108" name="Shape 105"/>
+          <p:cNvSpPr/>
+          <p:nvPr/>
+        </p:nvSpPr>
+        <p:spPr>
+          <a:xfrm>
+            <a:off x="2340864" y="3022092"/>
+            <a:ext cx="146304" cy="4572"/>
+          </a:xfrm>
+          <a:prstGeom prst="line">
+            <a:avLst/>
+          </a:prstGeom>
+          <a:noFill/>
+          <a:ln w="20320">
+            <a:solidFill>
+              <a:srgbClr val="94A3B8"/>
+            </a:solidFill>
+            <a:prstDash val="solid"/>
+          </a:ln>
+        </p:spPr>
+      </p:sp>
+      <p:sp>
+        <p:nvSpPr>
+          <p:cNvPr id="109" name="Shape 106"/>
+          <p:cNvSpPr/>
+          <p:nvPr/>
+        </p:nvSpPr>
+        <p:spPr>
+          <a:xfrm>
+            <a:off x="2340864" y="1591056"/>
+            <a:ext cx="4572" cy="1431036"/>
+          </a:xfrm>
+          <a:prstGeom prst="line">
+            <a:avLst/>
+          </a:prstGeom>
+          <a:noFill/>
+          <a:ln w="20320">
+            <a:solidFill>
+              <a:srgbClr val="94A3B8"/>
+            </a:solidFill>
+            <a:prstDash val="solid"/>
+          </a:ln>
+        </p:spPr>
+      </p:sp>
+      <p:sp>
+        <p:nvSpPr>
+          <p:cNvPr id="110" name="Shape 107"/>
+          <p:cNvSpPr/>
+          <p:nvPr/>
+        </p:nvSpPr>
+        <p:spPr>
+          <a:xfrm>
+            <a:off x="2194560" y="1591056"/>
+            <a:ext cx="146304" cy="4572"/>
+          </a:xfrm>
+          <a:prstGeom prst="line">
+            <a:avLst/>
+          </a:prstGeom>
+          <a:noFill/>
+          <a:ln w="20320">
+            <a:solidFill>
+              <a:srgbClr val="475569"/>
+            </a:solidFill>
+            <a:prstDash val="solid"/>
+            <a:tailEnd type="triangle"/>
+          </a:ln>
+        </p:spPr>
+      </p:sp>
+      <p:sp>
+        <p:nvSpPr>
+          <p:cNvPr id="111" name="Shape 108"/>
+          <p:cNvSpPr/>
+          <p:nvPr/>
+        </p:nvSpPr>
+        <p:spPr>
+          <a:xfrm>
+            <a:off x="1828800" y="2205990"/>
+            <a:ext cx="1024128" cy="201168"/>
+          </a:xfrm>
+          <a:prstGeom prst="roundRect">
+            <a:avLst>
+              <a:gd name="adj" fmla="val 22727"/>
+            </a:avLst>
+          </a:prstGeom>
+          <a:solidFill>
+            <a:srgbClr val="F8FAFC"/>
+          </a:solidFill>
+          <a:ln w="10160">
+            <a:solidFill>
+              <a:srgbClr val="CBD5E1"/>
+            </a:solidFill>
+            <a:prstDash val="solid"/>
+          </a:ln>
+        </p:spPr>
+      </p:sp>
+      <p:sp>
+        <p:nvSpPr>
+          <p:cNvPr id="112" name="Text 109"/>
+          <p:cNvSpPr/>
+          <p:nvPr/>
+        </p:nvSpPr>
+        <p:spPr>
+          <a:xfrm>
+            <a:off x="1828800" y="2205990"/>
+            <a:ext cx="1024128" cy="201168"/>
+          </a:xfrm>
+          <a:prstGeom prst="rect">
+            <a:avLst/>
+          </a:prstGeom>
+          <a:noFill/>
+          <a:ln/>
+        </p:spPr>
+        <p:txBody>
+          <a:bodyPr wrap="square" lIns="25400" tIns="25400" rIns="25400" bIns="25400" rtlCol="0" anchor="ctr"/>
+          <a:lstStyle/>
+          <a:p>
+            <a:pPr algn="ctr" indent="0" marL="0">
+              <a:buNone/>
+            </a:pPr>
+            <a:r>
+              <a:rPr lang="en-US" sz="650" dirty="0">
+                <a:solidFill>
+                  <a:srgbClr val="334155"/>
+                </a:solidFill>
+                <a:latin typeface="Calibri" pitchFamily="34" charset="0"/>
+                <a:ea typeface="Calibri" pitchFamily="34" charset="-122"/>
+                <a:cs typeface="Calibri" pitchFamily="34" charset="-120"/>
+              </a:rPr>
+              <a:t>Governance Report Download</a:t>
+            </a:r>
+            <a:endParaRPr lang="en-US" sz="650" dirty="0"/>
+          </a:p>
+        </p:txBody>
+      </p:sp>
     </p:spTree>
   </p:cSld>
   <p:clrMapOvr>

</xml_diff>